<commit_message>
Strengthen UNAD institutional identity in The Chorus deck
Enhance the recreated UNAD mark: the sun emblem now carries an open-arms
learner figure (head, torso, raised arms) evoking UNAD's identity, shown
full-color with a soft halo as a prominent institutional graphic on the
title and closing slides, with a larger header lockup throughout.

Co-Authored-By: Claude Opus 4.8 <noreply@anthropic.com>
Claude-Session: https://claude.ai/code/session_01TwVsfxhDNMSwKt7gxZg5wQ
</commit_message>
<xml_diff>
--- a/The_Chorus_Challenge3_UNAD.pptx
+++ b/The_Chorus_Challenge3_UNAD.pptx
@@ -2662,8 +2662,28 @@
         </p:nvSpPr>
         <p:spPr>
           <a:xfrm>
-            <a:off x="12487961" y="5896051"/>
-            <a:ext cx="868680" cy="277978"/>
+            <a:off x="9372600" y="3840480"/>
+            <a:ext cx="3291840" cy="3291840"/>
+          </a:xfrm>
+          <a:prstGeom prst="ellipse">
+            <a:avLst/>
+          </a:prstGeom>
+          <a:solidFill>
+            <a:srgbClr val="1A4C2C"/>
+          </a:solidFill>
+          <a:ln/>
+        </p:spPr>
+      </p:sp>
+      <p:sp>
+        <p:nvSpPr>
+          <p:cNvPr id="3" name="Shape 1"/>
+          <p:cNvSpPr/>
+          <p:nvPr/>
+        </p:nvSpPr>
+        <p:spPr>
+          <a:xfrm>
+            <a:off x="12035699" y="5407396"/>
+            <a:ext cx="493776" cy="158008"/>
           </a:xfrm>
           <a:prstGeom prst="roundRect">
             <a:avLst>
@@ -2671,21 +2691,21 @@
             </a:avLst>
           </a:prstGeom>
           <a:solidFill>
-            <a:srgbClr val="1F5E34"/>
-          </a:solidFill>
-          <a:ln/>
-        </p:spPr>
-      </p:sp>
-      <p:sp>
-        <p:nvSpPr>
-          <p:cNvPr id="3" name="Shape 1"/>
+            <a:srgbClr val="F2AD32"/>
+          </a:solidFill>
+          <a:ln/>
+        </p:spPr>
+      </p:sp>
+      <p:sp>
+        <p:nvSpPr>
+          <p:cNvPr id="4" name="Shape 2"/>
           <p:cNvSpPr/>
           <p:nvPr/>
         </p:nvSpPr>
         <p:spPr>
           <a:xfrm rot="1800000">
-            <a:off x="12190025" y="7007962"/>
-            <a:ext cx="868680" cy="277978"/>
+            <a:off x="11866346" y="6039429"/>
+            <a:ext cx="493776" cy="158008"/>
           </a:xfrm>
           <a:prstGeom prst="roundRect">
             <a:avLst>
@@ -2693,21 +2713,21 @@
             </a:avLst>
           </a:prstGeom>
           <a:solidFill>
-            <a:srgbClr val="1F5E34"/>
-          </a:solidFill>
-          <a:ln/>
-        </p:spPr>
-      </p:sp>
-      <p:sp>
-        <p:nvSpPr>
-          <p:cNvPr id="4" name="Shape 2"/>
+            <a:srgbClr val="4E9A3E"/>
+          </a:solidFill>
+          <a:ln/>
+        </p:spPr>
+      </p:sp>
+      <p:sp>
+        <p:nvSpPr>
+          <p:cNvPr id="5" name="Shape 3"/>
           <p:cNvSpPr/>
           <p:nvPr/>
         </p:nvSpPr>
         <p:spPr>
           <a:xfrm rot="3600000">
-            <a:off x="11376050" y="7821937"/>
-            <a:ext cx="868680" cy="277978"/>
+            <a:off x="11403665" y="6502110"/>
+            <a:ext cx="493776" cy="158008"/>
           </a:xfrm>
           <a:prstGeom prst="roundRect">
             <a:avLst>
@@ -2715,21 +2735,21 @@
             </a:avLst>
           </a:prstGeom>
           <a:solidFill>
-            <a:srgbClr val="1F5E34"/>
-          </a:solidFill>
-          <a:ln/>
-        </p:spPr>
-      </p:sp>
-      <p:sp>
-        <p:nvSpPr>
-          <p:cNvPr id="5" name="Shape 3"/>
+            <a:srgbClr val="F2AD32"/>
+          </a:solidFill>
+          <a:ln/>
+        </p:spPr>
+      </p:sp>
+      <p:sp>
+        <p:nvSpPr>
+          <p:cNvPr id="6" name="Shape 4"/>
           <p:cNvSpPr/>
           <p:nvPr/>
         </p:nvSpPr>
         <p:spPr>
           <a:xfrm rot="5400000">
-            <a:off x="10264140" y="8119872"/>
-            <a:ext cx="868680" cy="277978"/>
+            <a:off x="10771632" y="6671462"/>
+            <a:ext cx="493776" cy="158008"/>
           </a:xfrm>
           <a:prstGeom prst="roundRect">
             <a:avLst>
@@ -2737,21 +2757,21 @@
             </a:avLst>
           </a:prstGeom>
           <a:solidFill>
-            <a:srgbClr val="1F5E34"/>
-          </a:solidFill>
-          <a:ln/>
-        </p:spPr>
-      </p:sp>
-      <p:sp>
-        <p:nvSpPr>
-          <p:cNvPr id="6" name="Shape 4"/>
+            <a:srgbClr val="4E9A3E"/>
+          </a:solidFill>
+          <a:ln/>
+        </p:spPr>
+      </p:sp>
+      <p:sp>
+        <p:nvSpPr>
+          <p:cNvPr id="7" name="Shape 5"/>
           <p:cNvSpPr/>
           <p:nvPr/>
         </p:nvSpPr>
         <p:spPr>
           <a:xfrm rot="7200000">
-            <a:off x="9152230" y="7821937"/>
-            <a:ext cx="868680" cy="277978"/>
+            <a:off x="10139599" y="6502110"/>
+            <a:ext cx="493776" cy="158008"/>
           </a:xfrm>
           <a:prstGeom prst="roundRect">
             <a:avLst>
@@ -2759,21 +2779,21 @@
             </a:avLst>
           </a:prstGeom>
           <a:solidFill>
-            <a:srgbClr val="1F5E34"/>
-          </a:solidFill>
-          <a:ln/>
-        </p:spPr>
-      </p:sp>
-      <p:sp>
-        <p:nvSpPr>
-          <p:cNvPr id="7" name="Shape 5"/>
+            <a:srgbClr val="F2AD32"/>
+          </a:solidFill>
+          <a:ln/>
+        </p:spPr>
+      </p:sp>
+      <p:sp>
+        <p:nvSpPr>
+          <p:cNvPr id="8" name="Shape 6"/>
           <p:cNvSpPr/>
           <p:nvPr/>
         </p:nvSpPr>
         <p:spPr>
           <a:xfrm rot="9000000">
-            <a:off x="8338255" y="7007962"/>
-            <a:ext cx="868680" cy="277978"/>
+            <a:off x="9676918" y="6039429"/>
+            <a:ext cx="493776" cy="158008"/>
           </a:xfrm>
           <a:prstGeom prst="roundRect">
             <a:avLst>
@@ -2781,21 +2801,21 @@
             </a:avLst>
           </a:prstGeom>
           <a:solidFill>
-            <a:srgbClr val="1F5E34"/>
-          </a:solidFill>
-          <a:ln/>
-        </p:spPr>
-      </p:sp>
-      <p:sp>
-        <p:nvSpPr>
-          <p:cNvPr id="8" name="Shape 6"/>
+            <a:srgbClr val="4E9A3E"/>
+          </a:solidFill>
+          <a:ln/>
+        </p:spPr>
+      </p:sp>
+      <p:sp>
+        <p:nvSpPr>
+          <p:cNvPr id="9" name="Shape 7"/>
           <p:cNvSpPr/>
           <p:nvPr/>
         </p:nvSpPr>
         <p:spPr>
           <a:xfrm rot="10800000">
-            <a:off x="8040319" y="5896051"/>
-            <a:ext cx="868680" cy="277978"/>
+            <a:off x="9507565" y="5407396"/>
+            <a:ext cx="493776" cy="158008"/>
           </a:xfrm>
           <a:prstGeom prst="roundRect">
             <a:avLst>
@@ -2803,21 +2823,21 @@
             </a:avLst>
           </a:prstGeom>
           <a:solidFill>
-            <a:srgbClr val="1F5E34"/>
-          </a:solidFill>
-          <a:ln/>
-        </p:spPr>
-      </p:sp>
-      <p:sp>
-        <p:nvSpPr>
-          <p:cNvPr id="9" name="Shape 7"/>
+            <a:srgbClr val="F2AD32"/>
+          </a:solidFill>
+          <a:ln/>
+        </p:spPr>
+      </p:sp>
+      <p:sp>
+        <p:nvSpPr>
+          <p:cNvPr id="10" name="Shape 8"/>
           <p:cNvSpPr/>
           <p:nvPr/>
         </p:nvSpPr>
         <p:spPr>
           <a:xfrm rot="12600000">
-            <a:off x="8338255" y="4784141"/>
-            <a:ext cx="868680" cy="277978"/>
+            <a:off x="9676918" y="4775363"/>
+            <a:ext cx="493776" cy="158008"/>
           </a:xfrm>
           <a:prstGeom prst="roundRect">
             <a:avLst>
@@ -2825,21 +2845,21 @@
             </a:avLst>
           </a:prstGeom>
           <a:solidFill>
-            <a:srgbClr val="1F5E34"/>
-          </a:solidFill>
-          <a:ln/>
-        </p:spPr>
-      </p:sp>
-      <p:sp>
-        <p:nvSpPr>
-          <p:cNvPr id="10" name="Shape 8"/>
+            <a:srgbClr val="4E9A3E"/>
+          </a:solidFill>
+          <a:ln/>
+        </p:spPr>
+      </p:sp>
+      <p:sp>
+        <p:nvSpPr>
+          <p:cNvPr id="11" name="Shape 9"/>
           <p:cNvSpPr/>
           <p:nvPr/>
         </p:nvSpPr>
         <p:spPr>
           <a:xfrm rot="14400000">
-            <a:off x="9152230" y="3970166"/>
-            <a:ext cx="868680" cy="277978"/>
+            <a:off x="10139599" y="4312682"/>
+            <a:ext cx="493776" cy="158008"/>
           </a:xfrm>
           <a:prstGeom prst="roundRect">
             <a:avLst>
@@ -2847,21 +2867,21 @@
             </a:avLst>
           </a:prstGeom>
           <a:solidFill>
-            <a:srgbClr val="1F5E34"/>
-          </a:solidFill>
-          <a:ln/>
-        </p:spPr>
-      </p:sp>
-      <p:sp>
-        <p:nvSpPr>
-          <p:cNvPr id="11" name="Shape 9"/>
+            <a:srgbClr val="F2AD32"/>
+          </a:solidFill>
+          <a:ln/>
+        </p:spPr>
+      </p:sp>
+      <p:sp>
+        <p:nvSpPr>
+          <p:cNvPr id="12" name="Shape 10"/>
           <p:cNvSpPr/>
           <p:nvPr/>
         </p:nvSpPr>
         <p:spPr>
           <a:xfrm rot="16200000">
-            <a:off x="10264140" y="3672230"/>
-            <a:ext cx="868680" cy="277978"/>
+            <a:off x="10771632" y="4143329"/>
+            <a:ext cx="493776" cy="158008"/>
           </a:xfrm>
           <a:prstGeom prst="roundRect">
             <a:avLst>
@@ -2869,21 +2889,21 @@
             </a:avLst>
           </a:prstGeom>
           <a:solidFill>
-            <a:srgbClr val="1F5E34"/>
-          </a:solidFill>
-          <a:ln/>
-        </p:spPr>
-      </p:sp>
-      <p:sp>
-        <p:nvSpPr>
-          <p:cNvPr id="12" name="Shape 10"/>
+            <a:srgbClr val="4E9A3E"/>
+          </a:solidFill>
+          <a:ln/>
+        </p:spPr>
+      </p:sp>
+      <p:sp>
+        <p:nvSpPr>
+          <p:cNvPr id="13" name="Shape 11"/>
           <p:cNvSpPr/>
           <p:nvPr/>
         </p:nvSpPr>
         <p:spPr>
           <a:xfrm rot="18000000">
-            <a:off x="11376050" y="3970166"/>
-            <a:ext cx="868680" cy="277978"/>
+            <a:off x="11403665" y="4312682"/>
+            <a:ext cx="493776" cy="158008"/>
           </a:xfrm>
           <a:prstGeom prst="roundRect">
             <a:avLst>
@@ -2891,21 +2911,21 @@
             </a:avLst>
           </a:prstGeom>
           <a:solidFill>
-            <a:srgbClr val="1F5E34"/>
-          </a:solidFill>
-          <a:ln/>
-        </p:spPr>
-      </p:sp>
-      <p:sp>
-        <p:nvSpPr>
-          <p:cNvPr id="13" name="Shape 11"/>
+            <a:srgbClr val="F2AD32"/>
+          </a:solidFill>
+          <a:ln/>
+        </p:spPr>
+      </p:sp>
+      <p:sp>
+        <p:nvSpPr>
+          <p:cNvPr id="14" name="Shape 12"/>
           <p:cNvSpPr/>
           <p:nvPr/>
         </p:nvSpPr>
         <p:spPr>
           <a:xfrm rot="19800000">
-            <a:off x="12190025" y="4784141"/>
-            <a:ext cx="868680" cy="277978"/>
+            <a:off x="11866346" y="4775363"/>
+            <a:ext cx="493776" cy="158008"/>
           </a:xfrm>
           <a:prstGeom prst="roundRect">
             <a:avLst>
@@ -2913,61 +2933,61 @@
             </a:avLst>
           </a:prstGeom>
           <a:solidFill>
-            <a:srgbClr val="1F5E34"/>
-          </a:solidFill>
-          <a:ln/>
-        </p:spPr>
-      </p:sp>
-      <p:sp>
-        <p:nvSpPr>
-          <p:cNvPr id="14" name="Shape 12"/>
-          <p:cNvSpPr/>
-          <p:nvPr/>
-        </p:nvSpPr>
-        <p:spPr>
-          <a:xfrm>
-            <a:off x="8961120" y="4297680"/>
-            <a:ext cx="3474720" cy="3474720"/>
+            <a:srgbClr val="4E9A3E"/>
+          </a:solidFill>
+          <a:ln/>
+        </p:spPr>
+      </p:sp>
+      <p:sp>
+        <p:nvSpPr>
+          <p:cNvPr id="15" name="Shape 13"/>
+          <p:cNvSpPr/>
+          <p:nvPr/>
+        </p:nvSpPr>
+        <p:spPr>
+          <a:xfrm>
+            <a:off x="10030968" y="4498848"/>
+            <a:ext cx="1975104" cy="1975104"/>
           </a:xfrm>
           <a:prstGeom prst="ellipse">
             <a:avLst/>
           </a:prstGeom>
           <a:solidFill>
-            <a:srgbClr val="1F5E34"/>
-          </a:solidFill>
-          <a:ln/>
-        </p:spPr>
-      </p:sp>
-      <p:sp>
-        <p:nvSpPr>
-          <p:cNvPr id="15" name="Shape 13"/>
-          <p:cNvSpPr/>
-          <p:nvPr/>
-        </p:nvSpPr>
-        <p:spPr>
-          <a:xfrm>
-            <a:off x="9621317" y="4957877"/>
-            <a:ext cx="2154326" cy="2154326"/>
+            <a:srgbClr val="4E9A3E"/>
+          </a:solidFill>
+          <a:ln/>
+        </p:spPr>
+      </p:sp>
+      <p:sp>
+        <p:nvSpPr>
+          <p:cNvPr id="16" name="Shape 14"/>
+          <p:cNvSpPr/>
+          <p:nvPr/>
+        </p:nvSpPr>
+        <p:spPr>
+          <a:xfrm>
+            <a:off x="10406238" y="4874118"/>
+            <a:ext cx="1224564" cy="1224564"/>
           </a:xfrm>
           <a:prstGeom prst="ellipse">
             <a:avLst/>
           </a:prstGeom>
           <a:solidFill>
-            <a:srgbClr val="1A4C2C"/>
-          </a:solidFill>
-          <a:ln/>
-        </p:spPr>
-      </p:sp>
-      <p:sp>
-        <p:nvSpPr>
-          <p:cNvPr id="16" name="Shape 14"/>
-          <p:cNvSpPr/>
-          <p:nvPr/>
-        </p:nvSpPr>
-        <p:spPr>
-          <a:xfrm>
-            <a:off x="10351008" y="5444338"/>
-            <a:ext cx="694944" cy="694944"/>
+            <a:srgbClr val="F2AD32"/>
+          </a:solidFill>
+          <a:ln/>
+        </p:spPr>
+      </p:sp>
+      <p:sp>
+        <p:nvSpPr>
+          <p:cNvPr id="17" name="Shape 15"/>
+          <p:cNvSpPr/>
+          <p:nvPr/>
+        </p:nvSpPr>
+        <p:spPr>
+          <a:xfrm>
+            <a:off x="10870387" y="4972873"/>
+            <a:ext cx="296266" cy="296266"/>
           </a:xfrm>
           <a:prstGeom prst="ellipse">
             <a:avLst/>
@@ -2980,14 +3000,402 @@
       </p:sp>
       <p:sp>
         <p:nvSpPr>
-          <p:cNvPr id="17" name="Shape 15"/>
-          <p:cNvSpPr/>
-          <p:nvPr/>
-        </p:nvSpPr>
-        <p:spPr>
-          <a:xfrm>
-            <a:off x="9968789" y="5896051"/>
-            <a:ext cx="1459382" cy="1216152"/>
+          <p:cNvPr id="18" name="Shape 16"/>
+          <p:cNvSpPr/>
+          <p:nvPr/>
+        </p:nvSpPr>
+        <p:spPr>
+          <a:xfrm>
+            <a:off x="10761756" y="5348143"/>
+            <a:ext cx="513527" cy="553029"/>
+          </a:xfrm>
+          <a:prstGeom prst="triangle">
+            <a:avLst/>
+          </a:prstGeom>
+          <a:solidFill>
+            <a:srgbClr val="FFFFFF"/>
+          </a:solidFill>
+          <a:ln/>
+        </p:spPr>
+      </p:sp>
+      <p:sp>
+        <p:nvSpPr>
+          <p:cNvPr id="19" name="Shape 17"/>
+          <p:cNvSpPr/>
+          <p:nvPr/>
+        </p:nvSpPr>
+        <p:spPr>
+          <a:xfrm rot="-2520000">
+            <a:off x="10524744" y="5190134"/>
+            <a:ext cx="454274" cy="148133"/>
+          </a:xfrm>
+          <a:prstGeom prst="roundRect">
+            <a:avLst>
+              <a:gd name="adj" fmla="val 50000"/>
+            </a:avLst>
+          </a:prstGeom>
+          <a:solidFill>
+            <a:srgbClr val="FFFFFF"/>
+          </a:solidFill>
+          <a:ln/>
+        </p:spPr>
+      </p:sp>
+      <p:sp>
+        <p:nvSpPr>
+          <p:cNvPr id="20" name="Shape 18"/>
+          <p:cNvSpPr/>
+          <p:nvPr/>
+        </p:nvSpPr>
+        <p:spPr>
+          <a:xfrm rot="2520000">
+            <a:off x="11058022" y="5190134"/>
+            <a:ext cx="454274" cy="148133"/>
+          </a:xfrm>
+          <a:prstGeom prst="roundRect">
+            <a:avLst>
+              <a:gd name="adj" fmla="val 50000"/>
+            </a:avLst>
+          </a:prstGeom>
+          <a:solidFill>
+            <a:srgbClr val="FFFFFF"/>
+          </a:solidFill>
+          <a:ln/>
+        </p:spPr>
+      </p:sp>
+      <p:sp>
+        <p:nvSpPr>
+          <p:cNvPr id="21" name="Shape 19"/>
+          <p:cNvSpPr/>
+          <p:nvPr/>
+        </p:nvSpPr>
+        <p:spPr>
+          <a:xfrm>
+            <a:off x="891659" y="695054"/>
+            <a:ext cx="73609" cy="23555"/>
+          </a:xfrm>
+          <a:prstGeom prst="roundRect">
+            <a:avLst>
+              <a:gd name="adj" fmla="val 50000"/>
+            </a:avLst>
+          </a:prstGeom>
+          <a:solidFill>
+            <a:srgbClr val="F2AD32"/>
+          </a:solidFill>
+          <a:ln/>
+        </p:spPr>
+      </p:sp>
+      <p:sp>
+        <p:nvSpPr>
+          <p:cNvPr id="22" name="Shape 20"/>
+          <p:cNvSpPr/>
+          <p:nvPr/>
+        </p:nvSpPr>
+        <p:spPr>
+          <a:xfrm rot="1800000">
+            <a:off x="866413" y="789274"/>
+            <a:ext cx="73609" cy="23555"/>
+          </a:xfrm>
+          <a:prstGeom prst="roundRect">
+            <a:avLst>
+              <a:gd name="adj" fmla="val 50000"/>
+            </a:avLst>
+          </a:prstGeom>
+          <a:solidFill>
+            <a:srgbClr val="4E9A3E"/>
+          </a:solidFill>
+          <a:ln/>
+        </p:spPr>
+      </p:sp>
+      <p:sp>
+        <p:nvSpPr>
+          <p:cNvPr id="23" name="Shape 21"/>
+          <p:cNvSpPr/>
+          <p:nvPr/>
+        </p:nvSpPr>
+        <p:spPr>
+          <a:xfrm rot="3600000">
+            <a:off x="797439" y="858247"/>
+            <a:ext cx="73609" cy="23555"/>
+          </a:xfrm>
+          <a:prstGeom prst="roundRect">
+            <a:avLst>
+              <a:gd name="adj" fmla="val 50000"/>
+            </a:avLst>
+          </a:prstGeom>
+          <a:solidFill>
+            <a:srgbClr val="F2AD32"/>
+          </a:solidFill>
+          <a:ln/>
+        </p:spPr>
+      </p:sp>
+      <p:sp>
+        <p:nvSpPr>
+          <p:cNvPr id="24" name="Shape 22"/>
+          <p:cNvSpPr/>
+          <p:nvPr/>
+        </p:nvSpPr>
+        <p:spPr>
+          <a:xfrm rot="5400000">
+            <a:off x="703219" y="883493"/>
+            <a:ext cx="73609" cy="23555"/>
+          </a:xfrm>
+          <a:prstGeom prst="roundRect">
+            <a:avLst>
+              <a:gd name="adj" fmla="val 50000"/>
+            </a:avLst>
+          </a:prstGeom>
+          <a:solidFill>
+            <a:srgbClr val="4E9A3E"/>
+          </a:solidFill>
+          <a:ln/>
+        </p:spPr>
+      </p:sp>
+      <p:sp>
+        <p:nvSpPr>
+          <p:cNvPr id="25" name="Shape 23"/>
+          <p:cNvSpPr/>
+          <p:nvPr/>
+        </p:nvSpPr>
+        <p:spPr>
+          <a:xfrm rot="7200000">
+            <a:off x="609000" y="858247"/>
+            <a:ext cx="73609" cy="23555"/>
+          </a:xfrm>
+          <a:prstGeom prst="roundRect">
+            <a:avLst>
+              <a:gd name="adj" fmla="val 50000"/>
+            </a:avLst>
+          </a:prstGeom>
+          <a:solidFill>
+            <a:srgbClr val="F2AD32"/>
+          </a:solidFill>
+          <a:ln/>
+        </p:spPr>
+      </p:sp>
+      <p:sp>
+        <p:nvSpPr>
+          <p:cNvPr id="26" name="Shape 24"/>
+          <p:cNvSpPr/>
+          <p:nvPr/>
+        </p:nvSpPr>
+        <p:spPr>
+          <a:xfrm rot="9000000">
+            <a:off x="540026" y="789274"/>
+            <a:ext cx="73609" cy="23555"/>
+          </a:xfrm>
+          <a:prstGeom prst="roundRect">
+            <a:avLst>
+              <a:gd name="adj" fmla="val 50000"/>
+            </a:avLst>
+          </a:prstGeom>
+          <a:solidFill>
+            <a:srgbClr val="4E9A3E"/>
+          </a:solidFill>
+          <a:ln/>
+        </p:spPr>
+      </p:sp>
+      <p:sp>
+        <p:nvSpPr>
+          <p:cNvPr id="27" name="Shape 25"/>
+          <p:cNvSpPr/>
+          <p:nvPr/>
+        </p:nvSpPr>
+        <p:spPr>
+          <a:xfrm rot="10800000">
+            <a:off x="514780" y="695054"/>
+            <a:ext cx="73609" cy="23555"/>
+          </a:xfrm>
+          <a:prstGeom prst="roundRect">
+            <a:avLst>
+              <a:gd name="adj" fmla="val 50000"/>
+            </a:avLst>
+          </a:prstGeom>
+          <a:solidFill>
+            <a:srgbClr val="F2AD32"/>
+          </a:solidFill>
+          <a:ln/>
+        </p:spPr>
+      </p:sp>
+      <p:sp>
+        <p:nvSpPr>
+          <p:cNvPr id="28" name="Shape 26"/>
+          <p:cNvSpPr/>
+          <p:nvPr/>
+        </p:nvSpPr>
+        <p:spPr>
+          <a:xfrm rot="12600000">
+            <a:off x="540026" y="600834"/>
+            <a:ext cx="73609" cy="23555"/>
+          </a:xfrm>
+          <a:prstGeom prst="roundRect">
+            <a:avLst>
+              <a:gd name="adj" fmla="val 50000"/>
+            </a:avLst>
+          </a:prstGeom>
+          <a:solidFill>
+            <a:srgbClr val="4E9A3E"/>
+          </a:solidFill>
+          <a:ln/>
+        </p:spPr>
+      </p:sp>
+      <p:sp>
+        <p:nvSpPr>
+          <p:cNvPr id="29" name="Shape 27"/>
+          <p:cNvSpPr/>
+          <p:nvPr/>
+        </p:nvSpPr>
+        <p:spPr>
+          <a:xfrm rot="14400000">
+            <a:off x="609000" y="531860"/>
+            <a:ext cx="73609" cy="23555"/>
+          </a:xfrm>
+          <a:prstGeom prst="roundRect">
+            <a:avLst>
+              <a:gd name="adj" fmla="val 50000"/>
+            </a:avLst>
+          </a:prstGeom>
+          <a:solidFill>
+            <a:srgbClr val="F2AD32"/>
+          </a:solidFill>
+          <a:ln/>
+        </p:spPr>
+      </p:sp>
+      <p:sp>
+        <p:nvSpPr>
+          <p:cNvPr id="30" name="Shape 28"/>
+          <p:cNvSpPr/>
+          <p:nvPr/>
+        </p:nvSpPr>
+        <p:spPr>
+          <a:xfrm rot="16200000">
+            <a:off x="703219" y="506614"/>
+            <a:ext cx="73609" cy="23555"/>
+          </a:xfrm>
+          <a:prstGeom prst="roundRect">
+            <a:avLst>
+              <a:gd name="adj" fmla="val 50000"/>
+            </a:avLst>
+          </a:prstGeom>
+          <a:solidFill>
+            <a:srgbClr val="4E9A3E"/>
+          </a:solidFill>
+          <a:ln/>
+        </p:spPr>
+      </p:sp>
+      <p:sp>
+        <p:nvSpPr>
+          <p:cNvPr id="31" name="Shape 29"/>
+          <p:cNvSpPr/>
+          <p:nvPr/>
+        </p:nvSpPr>
+        <p:spPr>
+          <a:xfrm rot="18000000">
+            <a:off x="797439" y="531860"/>
+            <a:ext cx="73609" cy="23555"/>
+          </a:xfrm>
+          <a:prstGeom prst="roundRect">
+            <a:avLst>
+              <a:gd name="adj" fmla="val 50000"/>
+            </a:avLst>
+          </a:prstGeom>
+          <a:solidFill>
+            <a:srgbClr val="F2AD32"/>
+          </a:solidFill>
+          <a:ln/>
+        </p:spPr>
+      </p:sp>
+      <p:sp>
+        <p:nvSpPr>
+          <p:cNvPr id="32" name="Shape 30"/>
+          <p:cNvSpPr/>
+          <p:nvPr/>
+        </p:nvSpPr>
+        <p:spPr>
+          <a:xfrm rot="19800000">
+            <a:off x="866413" y="600834"/>
+            <a:ext cx="73609" cy="23555"/>
+          </a:xfrm>
+          <a:prstGeom prst="roundRect">
+            <a:avLst>
+              <a:gd name="adj" fmla="val 50000"/>
+            </a:avLst>
+          </a:prstGeom>
+          <a:solidFill>
+            <a:srgbClr val="4E9A3E"/>
+          </a:solidFill>
+          <a:ln/>
+        </p:spPr>
+      </p:sp>
+      <p:sp>
+        <p:nvSpPr>
+          <p:cNvPr id="33" name="Shape 31"/>
+          <p:cNvSpPr/>
+          <p:nvPr/>
+        </p:nvSpPr>
+        <p:spPr>
+          <a:xfrm>
+            <a:off x="592806" y="559613"/>
+            <a:ext cx="294437" cy="294437"/>
+          </a:xfrm>
+          <a:prstGeom prst="ellipse">
+            <a:avLst/>
+          </a:prstGeom>
+          <a:solidFill>
+            <a:srgbClr val="4E9A3E"/>
+          </a:solidFill>
+          <a:ln/>
+        </p:spPr>
+      </p:sp>
+      <p:sp>
+        <p:nvSpPr>
+          <p:cNvPr id="34" name="Shape 32"/>
+          <p:cNvSpPr/>
+          <p:nvPr/>
+        </p:nvSpPr>
+        <p:spPr>
+          <a:xfrm>
+            <a:off x="648749" y="615556"/>
+            <a:ext cx="182551" cy="182551"/>
+          </a:xfrm>
+          <a:prstGeom prst="ellipse">
+            <a:avLst/>
+          </a:prstGeom>
+          <a:solidFill>
+            <a:srgbClr val="F2AD32"/>
+          </a:solidFill>
+          <a:ln/>
+        </p:spPr>
+      </p:sp>
+      <p:sp>
+        <p:nvSpPr>
+          <p:cNvPr id="35" name="Shape 33"/>
+          <p:cNvSpPr/>
+          <p:nvPr/>
+        </p:nvSpPr>
+        <p:spPr>
+          <a:xfrm>
+            <a:off x="710580" y="656777"/>
+            <a:ext cx="58887" cy="58887"/>
+          </a:xfrm>
+          <a:prstGeom prst="ellipse">
+            <a:avLst/>
+          </a:prstGeom>
+          <a:solidFill>
+            <a:srgbClr val="FFFFFF"/>
+          </a:solidFill>
+          <a:ln/>
+        </p:spPr>
+      </p:sp>
+      <p:sp>
+        <p:nvSpPr>
+          <p:cNvPr id="36" name="Shape 34"/>
+          <p:cNvSpPr/>
+          <p:nvPr/>
+        </p:nvSpPr>
+        <p:spPr>
+          <a:xfrm>
+            <a:off x="678192" y="695054"/>
+            <a:ext cx="123663" cy="103053"/>
           </a:xfrm>
           <a:prstGeom prst="chord">
             <a:avLst>
@@ -3003,361 +3411,14 @@
       </p:sp>
       <p:sp>
         <p:nvSpPr>
-          <p:cNvPr id="18" name="Shape 16"/>
-          <p:cNvSpPr/>
-          <p:nvPr/>
-        </p:nvSpPr>
-        <p:spPr>
-          <a:xfrm>
-            <a:off x="846917" y="693847"/>
-            <a:ext cx="64008" cy="20483"/>
-          </a:xfrm>
-          <a:prstGeom prst="roundRect">
-            <a:avLst>
-              <a:gd name="adj" fmla="val 49999"/>
-            </a:avLst>
-          </a:prstGeom>
-          <a:solidFill>
-            <a:srgbClr val="F2AD32"/>
-          </a:solidFill>
-          <a:ln/>
-        </p:spPr>
-      </p:sp>
-      <p:sp>
-        <p:nvSpPr>
-          <p:cNvPr id="19" name="Shape 17"/>
-          <p:cNvSpPr/>
-          <p:nvPr/>
-        </p:nvSpPr>
-        <p:spPr>
-          <a:xfrm rot="1800000">
-            <a:off x="824964" y="775777"/>
-            <a:ext cx="64008" cy="20483"/>
-          </a:xfrm>
-          <a:prstGeom prst="roundRect">
-            <a:avLst>
-              <a:gd name="adj" fmla="val 49999"/>
-            </a:avLst>
-          </a:prstGeom>
-          <a:solidFill>
-            <a:srgbClr val="4E9A3E"/>
-          </a:solidFill>
-          <a:ln/>
-        </p:spPr>
-      </p:sp>
-      <p:sp>
-        <p:nvSpPr>
-          <p:cNvPr id="20" name="Shape 18"/>
-          <p:cNvSpPr/>
-          <p:nvPr/>
-        </p:nvSpPr>
-        <p:spPr>
-          <a:xfrm rot="3600000">
-            <a:off x="764987" y="835754"/>
-            <a:ext cx="64008" cy="20483"/>
-          </a:xfrm>
-          <a:prstGeom prst="roundRect">
-            <a:avLst>
-              <a:gd name="adj" fmla="val 49999"/>
-            </a:avLst>
-          </a:prstGeom>
-          <a:solidFill>
-            <a:srgbClr val="F2AD32"/>
-          </a:solidFill>
-          <a:ln/>
-        </p:spPr>
-      </p:sp>
-      <p:sp>
-        <p:nvSpPr>
-          <p:cNvPr id="21" name="Shape 19"/>
-          <p:cNvSpPr/>
-          <p:nvPr/>
-        </p:nvSpPr>
-        <p:spPr>
-          <a:xfrm rot="5400000">
-            <a:off x="683057" y="857707"/>
-            <a:ext cx="64008" cy="20483"/>
-          </a:xfrm>
-          <a:prstGeom prst="roundRect">
-            <a:avLst>
-              <a:gd name="adj" fmla="val 49999"/>
-            </a:avLst>
-          </a:prstGeom>
-          <a:solidFill>
-            <a:srgbClr val="4E9A3E"/>
-          </a:solidFill>
-          <a:ln/>
-        </p:spPr>
-      </p:sp>
-      <p:sp>
-        <p:nvSpPr>
-          <p:cNvPr id="22" name="Shape 20"/>
-          <p:cNvSpPr/>
-          <p:nvPr/>
-        </p:nvSpPr>
-        <p:spPr>
-          <a:xfrm rot="7200000">
-            <a:off x="601127" y="835754"/>
-            <a:ext cx="64008" cy="20483"/>
-          </a:xfrm>
-          <a:prstGeom prst="roundRect">
-            <a:avLst>
-              <a:gd name="adj" fmla="val 49999"/>
-            </a:avLst>
-          </a:prstGeom>
-          <a:solidFill>
-            <a:srgbClr val="F2AD32"/>
-          </a:solidFill>
-          <a:ln/>
-        </p:spPr>
-      </p:sp>
-      <p:sp>
-        <p:nvSpPr>
-          <p:cNvPr id="23" name="Shape 21"/>
-          <p:cNvSpPr/>
-          <p:nvPr/>
-        </p:nvSpPr>
-        <p:spPr>
-          <a:xfrm rot="9000000">
-            <a:off x="541149" y="775777"/>
-            <a:ext cx="64008" cy="20483"/>
-          </a:xfrm>
-          <a:prstGeom prst="roundRect">
-            <a:avLst>
-              <a:gd name="adj" fmla="val 49999"/>
-            </a:avLst>
-          </a:prstGeom>
-          <a:solidFill>
-            <a:srgbClr val="4E9A3E"/>
-          </a:solidFill>
-          <a:ln/>
-        </p:spPr>
-      </p:sp>
-      <p:sp>
-        <p:nvSpPr>
-          <p:cNvPr id="24" name="Shape 22"/>
-          <p:cNvSpPr/>
-          <p:nvPr/>
-        </p:nvSpPr>
-        <p:spPr>
-          <a:xfrm rot="10800000">
-            <a:off x="519196" y="693847"/>
-            <a:ext cx="64008" cy="20483"/>
-          </a:xfrm>
-          <a:prstGeom prst="roundRect">
-            <a:avLst>
-              <a:gd name="adj" fmla="val 49999"/>
-            </a:avLst>
-          </a:prstGeom>
-          <a:solidFill>
-            <a:srgbClr val="F2AD32"/>
-          </a:solidFill>
-          <a:ln/>
-        </p:spPr>
-      </p:sp>
-      <p:sp>
-        <p:nvSpPr>
-          <p:cNvPr id="25" name="Shape 23"/>
-          <p:cNvSpPr/>
-          <p:nvPr/>
-        </p:nvSpPr>
-        <p:spPr>
-          <a:xfrm rot="12600000">
-            <a:off x="541149" y="611916"/>
-            <a:ext cx="64008" cy="20483"/>
-          </a:xfrm>
-          <a:prstGeom prst="roundRect">
-            <a:avLst>
-              <a:gd name="adj" fmla="val 49999"/>
-            </a:avLst>
-          </a:prstGeom>
-          <a:solidFill>
-            <a:srgbClr val="4E9A3E"/>
-          </a:solidFill>
-          <a:ln/>
-        </p:spPr>
-      </p:sp>
-      <p:sp>
-        <p:nvSpPr>
-          <p:cNvPr id="26" name="Shape 24"/>
-          <p:cNvSpPr/>
-          <p:nvPr/>
-        </p:nvSpPr>
-        <p:spPr>
-          <a:xfrm rot="14400000">
-            <a:off x="601127" y="551939"/>
-            <a:ext cx="64008" cy="20483"/>
-          </a:xfrm>
-          <a:prstGeom prst="roundRect">
-            <a:avLst>
-              <a:gd name="adj" fmla="val 49999"/>
-            </a:avLst>
-          </a:prstGeom>
-          <a:solidFill>
-            <a:srgbClr val="F2AD32"/>
-          </a:solidFill>
-          <a:ln/>
-        </p:spPr>
-      </p:sp>
-      <p:sp>
-        <p:nvSpPr>
-          <p:cNvPr id="27" name="Shape 25"/>
-          <p:cNvSpPr/>
-          <p:nvPr/>
-        </p:nvSpPr>
-        <p:spPr>
-          <a:xfrm rot="16200000">
-            <a:off x="683057" y="529986"/>
-            <a:ext cx="64008" cy="20483"/>
-          </a:xfrm>
-          <a:prstGeom prst="roundRect">
-            <a:avLst>
-              <a:gd name="adj" fmla="val 49999"/>
-            </a:avLst>
-          </a:prstGeom>
-          <a:solidFill>
-            <a:srgbClr val="4E9A3E"/>
-          </a:solidFill>
-          <a:ln/>
-        </p:spPr>
-      </p:sp>
-      <p:sp>
-        <p:nvSpPr>
-          <p:cNvPr id="28" name="Shape 26"/>
-          <p:cNvSpPr/>
-          <p:nvPr/>
-        </p:nvSpPr>
-        <p:spPr>
-          <a:xfrm rot="18000000">
-            <a:off x="764987" y="551939"/>
-            <a:ext cx="64008" cy="20483"/>
-          </a:xfrm>
-          <a:prstGeom prst="roundRect">
-            <a:avLst>
-              <a:gd name="adj" fmla="val 49999"/>
-            </a:avLst>
-          </a:prstGeom>
-          <a:solidFill>
-            <a:srgbClr val="F2AD32"/>
-          </a:solidFill>
-          <a:ln/>
-        </p:spPr>
-      </p:sp>
-      <p:sp>
-        <p:nvSpPr>
-          <p:cNvPr id="29" name="Shape 27"/>
-          <p:cNvSpPr/>
-          <p:nvPr/>
-        </p:nvSpPr>
-        <p:spPr>
-          <a:xfrm rot="19800000">
-            <a:off x="824964" y="611916"/>
-            <a:ext cx="64008" cy="20483"/>
-          </a:xfrm>
-          <a:prstGeom prst="roundRect">
-            <a:avLst>
-              <a:gd name="adj" fmla="val 49999"/>
-            </a:avLst>
-          </a:prstGeom>
-          <a:solidFill>
-            <a:srgbClr val="4E9A3E"/>
-          </a:solidFill>
-          <a:ln/>
-        </p:spPr>
-      </p:sp>
-      <p:sp>
-        <p:nvSpPr>
-          <p:cNvPr id="30" name="Shape 28"/>
-          <p:cNvSpPr/>
-          <p:nvPr/>
-        </p:nvSpPr>
-        <p:spPr>
-          <a:xfrm>
-            <a:off x="587045" y="576072"/>
-            <a:ext cx="256032" cy="256032"/>
-          </a:xfrm>
-          <a:prstGeom prst="ellipse">
-            <a:avLst/>
-          </a:prstGeom>
-          <a:solidFill>
-            <a:srgbClr val="4E9A3E"/>
-          </a:solidFill>
-          <a:ln/>
-        </p:spPr>
-      </p:sp>
-      <p:sp>
-        <p:nvSpPr>
-          <p:cNvPr id="31" name="Shape 29"/>
-          <p:cNvSpPr/>
-          <p:nvPr/>
-        </p:nvSpPr>
-        <p:spPr>
-          <a:xfrm>
-            <a:off x="635691" y="624718"/>
-            <a:ext cx="158740" cy="158740"/>
-          </a:xfrm>
-          <a:prstGeom prst="ellipse">
-            <a:avLst/>
-          </a:prstGeom>
-          <a:solidFill>
-            <a:srgbClr val="F2AD32"/>
-          </a:solidFill>
-          <a:ln/>
-        </p:spPr>
-      </p:sp>
-      <p:sp>
-        <p:nvSpPr>
-          <p:cNvPr id="32" name="Shape 30"/>
-          <p:cNvSpPr/>
-          <p:nvPr/>
-        </p:nvSpPr>
-        <p:spPr>
-          <a:xfrm>
-            <a:off x="689458" y="660563"/>
-            <a:ext cx="51206" cy="51206"/>
-          </a:xfrm>
-          <a:prstGeom prst="ellipse">
-            <a:avLst/>
-          </a:prstGeom>
-          <a:solidFill>
-            <a:srgbClr val="FFFFFF"/>
-          </a:solidFill>
-          <a:ln/>
-        </p:spPr>
-      </p:sp>
-      <p:sp>
-        <p:nvSpPr>
-          <p:cNvPr id="33" name="Shape 31"/>
-          <p:cNvSpPr/>
-          <p:nvPr/>
-        </p:nvSpPr>
-        <p:spPr>
-          <a:xfrm>
-            <a:off x="661294" y="693847"/>
-            <a:ext cx="107533" cy="89611"/>
-          </a:xfrm>
-          <a:prstGeom prst="chord">
-            <a:avLst>
-              <a:gd name="adj1" fmla="val 10800000"/>
-              <a:gd name="adj2" fmla="val 21600000"/>
-            </a:avLst>
-          </a:prstGeom>
-          <a:solidFill>
-            <a:srgbClr val="FFFFFF"/>
-          </a:solidFill>
-          <a:ln/>
-        </p:spPr>
-      </p:sp>
-      <p:sp>
-        <p:nvSpPr>
-          <p:cNvPr id="34" name="Text 32"/>
+          <p:cNvPr id="37" name="Text 35"/>
           <p:cNvSpPr txBox="1"/>
           <p:nvPr/>
         </p:nvSpPr>
         <p:spPr>
           <a:xfrm>
-            <a:off x="907085" y="484632"/>
-            <a:ext cx="2377440" cy="274320"/>
+            <a:off x="960852" y="454457"/>
+            <a:ext cx="2734056" cy="315468"/>
           </a:xfrm>
           <a:prstGeom prst="rect">
             <a:avLst/>
@@ -3373,7 +3434,7 @@
               <a:buNone/>
             </a:pPr>
             <a:r>
-              <a:rPr lang="en-US" sz="1800" b="1" spc="100" kern="0" dirty="0">
+              <a:rPr lang="en-US" sz="2070" b="1" spc="100" kern="0" dirty="0">
                 <a:solidFill>
                   <a:srgbClr val="FFFFFF"/>
                 </a:solidFill>
@@ -3383,20 +3444,20 @@
               </a:rPr>
               <a:t>UNAD</a:t>
             </a:r>
-            <a:endParaRPr lang="en-US" sz="1800" dirty="0"/>
-          </a:p>
-        </p:txBody>
-      </p:sp>
-      <p:sp>
-        <p:nvSpPr>
-          <p:cNvPr id="35" name="Text 33"/>
+            <a:endParaRPr lang="en-US" sz="2070" dirty="0"/>
+          </a:p>
+        </p:txBody>
+      </p:sp>
+      <p:sp>
+        <p:nvSpPr>
+          <p:cNvPr id="38" name="Text 36"/>
           <p:cNvSpPr txBox="1"/>
           <p:nvPr/>
         </p:nvSpPr>
         <p:spPr>
           <a:xfrm>
-            <a:off x="907085" y="722376"/>
-            <a:ext cx="3017520" cy="182880"/>
+            <a:off x="960852" y="727862"/>
+            <a:ext cx="3470148" cy="210312"/>
           </a:xfrm>
           <a:prstGeom prst="rect">
             <a:avLst/>
@@ -3412,7 +3473,7 @@
               <a:buNone/>
             </a:pPr>
             <a:r>
-              <a:rPr lang="en-US" sz="750" dirty="0">
+              <a:rPr lang="en-US" sz="863" dirty="0">
                 <a:solidFill>
                   <a:srgbClr val="CFE3C4"/>
                 </a:solidFill>
@@ -3422,13 +3483,13 @@
               </a:rPr>
               <a:t>Universidad Nacional Abierta y a Distancia</a:t>
             </a:r>
-            <a:endParaRPr lang="en-US" sz="750" dirty="0"/>
-          </a:p>
-        </p:txBody>
-      </p:sp>
-      <p:sp>
-        <p:nvSpPr>
-          <p:cNvPr id="36" name="Text 34"/>
+            <a:endParaRPr lang="en-US" sz="863" dirty="0"/>
+          </a:p>
+        </p:txBody>
+      </p:sp>
+      <p:sp>
+        <p:nvSpPr>
+          <p:cNvPr id="39" name="Text 37"/>
           <p:cNvSpPr txBox="1"/>
           <p:nvPr/>
         </p:nvSpPr>
@@ -3467,7 +3528,7 @@
       </p:sp>
       <p:sp>
         <p:nvSpPr>
-          <p:cNvPr id="37" name="Text 35"/>
+          <p:cNvPr id="40" name="Text 38"/>
           <p:cNvSpPr txBox="1"/>
           <p:nvPr/>
         </p:nvSpPr>
@@ -3506,7 +3567,7 @@
       </p:sp>
       <p:sp>
         <p:nvSpPr>
-          <p:cNvPr id="38" name="Text 36"/>
+          <p:cNvPr id="41" name="Text 39"/>
           <p:cNvSpPr txBox="1"/>
           <p:nvPr/>
         </p:nvSpPr>
@@ -3545,7 +3606,7 @@
       </p:sp>
       <p:sp>
         <p:nvSpPr>
-          <p:cNvPr id="39" name="Shape 37"/>
+          <p:cNvPr id="42" name="Shape 40"/>
           <p:cNvSpPr/>
           <p:nvPr/>
         </p:nvSpPr>
@@ -3567,7 +3628,7 @@
       </p:sp>
       <p:sp>
         <p:nvSpPr>
-          <p:cNvPr id="40" name="Text 38"/>
+          <p:cNvPr id="43" name="Text 41"/>
           <p:cNvSpPr txBox="1"/>
           <p:nvPr/>
         </p:nvSpPr>
@@ -3620,7 +3681,7 @@
       </p:sp>
       <p:sp>
         <p:nvSpPr>
-          <p:cNvPr id="41" name="Text 39"/>
+          <p:cNvPr id="44" name="Text 42"/>
           <p:cNvSpPr txBox="1"/>
           <p:nvPr/>
         </p:nvSpPr>
@@ -3701,7 +3762,7 @@
       </p:sp>
       <p:sp>
         <p:nvSpPr>
-          <p:cNvPr id="42" name="Shape 40"/>
+          <p:cNvPr id="45" name="Shape 43"/>
           <p:cNvSpPr/>
           <p:nvPr/>
         </p:nvSpPr>
@@ -3728,7 +3789,7 @@
       </p:sp>
       <p:pic>
         <p:nvPicPr>
-          <p:cNvPr id="43" name="Image 0" descr="preencoded.png">    </p:cNvPr>
+          <p:cNvPr id="46" name="Image 0" descr="preencoded.png">    </p:cNvPr>
           <p:cNvPicPr>
             <a:picLocks noChangeAspect="1"/>
           </p:cNvPicPr>
@@ -3752,7 +3813,7 @@
       </p:pic>
       <p:sp>
         <p:nvSpPr>
-          <p:cNvPr id="44" name="Text 41"/>
+          <p:cNvPr id="47" name="Text 44"/>
           <p:cNvSpPr txBox="1"/>
           <p:nvPr/>
         </p:nvSpPr>
@@ -6455,8 +6516,8 @@
         </p:nvSpPr>
         <p:spPr>
           <a:xfrm>
-            <a:off x="10821010" y="4711720"/>
-            <a:ext cx="212141" cy="212141"/>
+            <a:off x="10847527" y="4616257"/>
+            <a:ext cx="159106" cy="159106"/>
           </a:xfrm>
           <a:prstGeom prst="ellipse">
             <a:avLst/>
@@ -6475,13 +6536,54 @@
         </p:nvSpPr>
         <p:spPr>
           <a:xfrm>
-            <a:off x="10704332" y="4849612"/>
-            <a:ext cx="445496" cy="371246"/>
-          </a:xfrm>
-          <a:prstGeom prst="chord">
+            <a:off x="10789188" y="4817791"/>
+            <a:ext cx="275783" cy="296997"/>
+          </a:xfrm>
+          <a:prstGeom prst="triangle">
+            <a:avLst/>
+          </a:prstGeom>
+          <a:solidFill>
+            <a:srgbClr val="FFFFFF"/>
+          </a:solidFill>
+          <a:ln/>
+        </p:spPr>
+      </p:sp>
+      <p:sp>
+        <p:nvSpPr>
+          <p:cNvPr id="40" name="Shape 33"/>
+          <p:cNvSpPr/>
+          <p:nvPr/>
+        </p:nvSpPr>
+        <p:spPr>
+          <a:xfrm rot="-2520000">
+            <a:off x="10661904" y="4732934"/>
+            <a:ext cx="243962" cy="79553"/>
+          </a:xfrm>
+          <a:prstGeom prst="roundRect">
             <a:avLst>
-              <a:gd name="adj1" fmla="val 10800000"/>
-              <a:gd name="adj2" fmla="val 21600000"/>
+              <a:gd name="adj" fmla="val 50000"/>
+            </a:avLst>
+          </a:prstGeom>
+          <a:solidFill>
+            <a:srgbClr val="FFFFFF"/>
+          </a:solidFill>
+          <a:ln/>
+        </p:spPr>
+      </p:sp>
+      <p:sp>
+        <p:nvSpPr>
+          <p:cNvPr id="41" name="Shape 34"/>
+          <p:cNvSpPr/>
+          <p:nvPr/>
+        </p:nvSpPr>
+        <p:spPr>
+          <a:xfrm rot="2520000">
+            <a:off x="10948294" y="4732934"/>
+            <a:ext cx="243962" cy="79553"/>
+          </a:xfrm>
+          <a:prstGeom prst="roundRect">
+            <a:avLst>
+              <a:gd name="adj" fmla="val 50000"/>
             </a:avLst>
           </a:prstGeom>
           <a:solidFill>
@@ -6492,7 +6594,7 @@
       </p:sp>
       <p:pic>
         <p:nvPicPr>
-          <p:cNvPr id="40" name="Image 5" descr="preencoded.png">    </p:cNvPr>
+          <p:cNvPr id="42" name="Image 5" descr="preencoded.png">    </p:cNvPr>
           <p:cNvPicPr>
             <a:picLocks noChangeAspect="1"/>
           </p:cNvPicPr>
@@ -6516,7 +6618,7 @@
       </p:pic>
       <p:sp>
         <p:nvSpPr>
-          <p:cNvPr id="41" name="Text 33"/>
+          <p:cNvPr id="43" name="Text 35"/>
           <p:cNvSpPr txBox="1"/>
           <p:nvPr/>
         </p:nvSpPr>
@@ -6555,7 +6657,7 @@
       </p:sp>
       <p:sp>
         <p:nvSpPr>
-          <p:cNvPr id="42" name="Text 34"/>
+          <p:cNvPr id="44" name="Text 36"/>
           <p:cNvSpPr txBox="1"/>
           <p:nvPr/>
         </p:nvSpPr>
@@ -11456,8 +11558,28 @@
         </p:nvSpPr>
         <p:spPr>
           <a:xfrm>
-            <a:off x="12490704" y="5797296"/>
-            <a:ext cx="914400" cy="292608"/>
+            <a:off x="9235440" y="4251960"/>
+            <a:ext cx="3383280" cy="3383280"/>
+          </a:xfrm>
+          <a:prstGeom prst="ellipse">
+            <a:avLst/>
+          </a:prstGeom>
+          <a:solidFill>
+            <a:srgbClr val="1A4C2C"/>
+          </a:solidFill>
+          <a:ln/>
+        </p:spPr>
+      </p:sp>
+      <p:sp>
+        <p:nvSpPr>
+          <p:cNvPr id="3" name="Shape 1"/>
+          <p:cNvSpPr/>
+          <p:nvPr/>
+        </p:nvSpPr>
+        <p:spPr>
+          <a:xfrm>
+            <a:off x="11981932" y="5861670"/>
+            <a:ext cx="512064" cy="163860"/>
           </a:xfrm>
           <a:prstGeom prst="roundRect">
             <a:avLst>
@@ -11465,21 +11587,21 @@
             </a:avLst>
           </a:prstGeom>
           <a:solidFill>
-            <a:srgbClr val="1F5E34"/>
-          </a:solidFill>
-          <a:ln/>
-        </p:spPr>
-      </p:sp>
-      <p:sp>
-        <p:nvSpPr>
-          <p:cNvPr id="3" name="Shape 1"/>
+            <a:srgbClr val="F2AD32"/>
+          </a:solidFill>
+          <a:ln/>
+        </p:spPr>
+      </p:sp>
+      <p:sp>
+        <p:nvSpPr>
+          <p:cNvPr id="4" name="Shape 2"/>
           <p:cNvSpPr/>
           <p:nvPr/>
         </p:nvSpPr>
         <p:spPr>
           <a:xfrm rot="1800000">
-            <a:off x="12177088" y="6967728"/>
-            <a:ext cx="914400" cy="292608"/>
+            <a:off x="11806307" y="6517112"/>
+            <a:ext cx="512064" cy="163860"/>
           </a:xfrm>
           <a:prstGeom prst="roundRect">
             <a:avLst>
@@ -11487,21 +11609,21 @@
             </a:avLst>
           </a:prstGeom>
           <a:solidFill>
-            <a:srgbClr val="1F5E34"/>
-          </a:solidFill>
-          <a:ln/>
-        </p:spPr>
-      </p:sp>
-      <p:sp>
-        <p:nvSpPr>
-          <p:cNvPr id="4" name="Shape 2"/>
+            <a:srgbClr val="4E9A3E"/>
+          </a:solidFill>
+          <a:ln/>
+        </p:spPr>
+      </p:sp>
+      <p:sp>
+        <p:nvSpPr>
+          <p:cNvPr id="5" name="Shape 3"/>
           <p:cNvSpPr/>
           <p:nvPr/>
         </p:nvSpPr>
         <p:spPr>
           <a:xfrm rot="3600000">
-            <a:off x="11320272" y="7824544"/>
-            <a:ext cx="914400" cy="292608"/>
+            <a:off x="11326490" y="6996928"/>
+            <a:ext cx="512064" cy="163860"/>
           </a:xfrm>
           <a:prstGeom prst="roundRect">
             <a:avLst>
@@ -11509,21 +11631,21 @@
             </a:avLst>
           </a:prstGeom>
           <a:solidFill>
-            <a:srgbClr val="1F5E34"/>
-          </a:solidFill>
-          <a:ln/>
-        </p:spPr>
-      </p:sp>
-      <p:sp>
-        <p:nvSpPr>
-          <p:cNvPr id="5" name="Shape 3"/>
+            <a:srgbClr val="F2AD32"/>
+          </a:solidFill>
+          <a:ln/>
+        </p:spPr>
+      </p:sp>
+      <p:sp>
+        <p:nvSpPr>
+          <p:cNvPr id="6" name="Shape 4"/>
           <p:cNvSpPr/>
           <p:nvPr/>
         </p:nvSpPr>
         <p:spPr>
           <a:xfrm rot="5400000">
-            <a:off x="10149840" y="8138160"/>
-            <a:ext cx="914400" cy="292608"/>
+            <a:off x="10671048" y="7172554"/>
+            <a:ext cx="512064" cy="163860"/>
           </a:xfrm>
           <a:prstGeom prst="roundRect">
             <a:avLst>
@@ -11531,21 +11653,21 @@
             </a:avLst>
           </a:prstGeom>
           <a:solidFill>
-            <a:srgbClr val="1F5E34"/>
-          </a:solidFill>
-          <a:ln/>
-        </p:spPr>
-      </p:sp>
-      <p:sp>
-        <p:nvSpPr>
-          <p:cNvPr id="6" name="Shape 4"/>
+            <a:srgbClr val="4E9A3E"/>
+          </a:solidFill>
+          <a:ln/>
+        </p:spPr>
+      </p:sp>
+      <p:sp>
+        <p:nvSpPr>
+          <p:cNvPr id="7" name="Shape 5"/>
           <p:cNvSpPr/>
           <p:nvPr/>
         </p:nvSpPr>
         <p:spPr>
           <a:xfrm rot="7200000">
-            <a:off x="8979408" y="7824544"/>
-            <a:ext cx="914400" cy="292608"/>
+            <a:off x="10015606" y="6996928"/>
+            <a:ext cx="512064" cy="163860"/>
           </a:xfrm>
           <a:prstGeom prst="roundRect">
             <a:avLst>
@@ -11553,21 +11675,21 @@
             </a:avLst>
           </a:prstGeom>
           <a:solidFill>
-            <a:srgbClr val="1F5E34"/>
-          </a:solidFill>
-          <a:ln/>
-        </p:spPr>
-      </p:sp>
-      <p:sp>
-        <p:nvSpPr>
-          <p:cNvPr id="7" name="Shape 5"/>
+            <a:srgbClr val="F2AD32"/>
+          </a:solidFill>
+          <a:ln/>
+        </p:spPr>
+      </p:sp>
+      <p:sp>
+        <p:nvSpPr>
+          <p:cNvPr id="8" name="Shape 6"/>
           <p:cNvSpPr/>
           <p:nvPr/>
         </p:nvSpPr>
         <p:spPr>
           <a:xfrm rot="9000000">
-            <a:off x="8122592" y="6967728"/>
-            <a:ext cx="914400" cy="292608"/>
+            <a:off x="9535789" y="6517112"/>
+            <a:ext cx="512064" cy="163860"/>
           </a:xfrm>
           <a:prstGeom prst="roundRect">
             <a:avLst>
@@ -11575,21 +11697,21 @@
             </a:avLst>
           </a:prstGeom>
           <a:solidFill>
-            <a:srgbClr val="1F5E34"/>
-          </a:solidFill>
-          <a:ln/>
-        </p:spPr>
-      </p:sp>
-      <p:sp>
-        <p:nvSpPr>
-          <p:cNvPr id="8" name="Shape 6"/>
+            <a:srgbClr val="4E9A3E"/>
+          </a:solidFill>
+          <a:ln/>
+        </p:spPr>
+      </p:sp>
+      <p:sp>
+        <p:nvSpPr>
+          <p:cNvPr id="9" name="Shape 7"/>
           <p:cNvSpPr/>
           <p:nvPr/>
         </p:nvSpPr>
         <p:spPr>
           <a:xfrm rot="10800000">
-            <a:off x="7808976" y="5797296"/>
-            <a:ext cx="914400" cy="292608"/>
+            <a:off x="9360164" y="5861670"/>
+            <a:ext cx="512064" cy="163860"/>
           </a:xfrm>
           <a:prstGeom prst="roundRect">
             <a:avLst>
@@ -11597,21 +11719,21 @@
             </a:avLst>
           </a:prstGeom>
           <a:solidFill>
-            <a:srgbClr val="1F5E34"/>
-          </a:solidFill>
-          <a:ln/>
-        </p:spPr>
-      </p:sp>
-      <p:sp>
-        <p:nvSpPr>
-          <p:cNvPr id="9" name="Shape 7"/>
+            <a:srgbClr val="F2AD32"/>
+          </a:solidFill>
+          <a:ln/>
+        </p:spPr>
+      </p:sp>
+      <p:sp>
+        <p:nvSpPr>
+          <p:cNvPr id="10" name="Shape 8"/>
           <p:cNvSpPr/>
           <p:nvPr/>
         </p:nvSpPr>
         <p:spPr>
           <a:xfrm rot="12600000">
-            <a:off x="8122592" y="4626864"/>
-            <a:ext cx="914400" cy="292608"/>
+            <a:off x="9535789" y="5206228"/>
+            <a:ext cx="512064" cy="163860"/>
           </a:xfrm>
           <a:prstGeom prst="roundRect">
             <a:avLst>
@@ -11619,21 +11741,21 @@
             </a:avLst>
           </a:prstGeom>
           <a:solidFill>
-            <a:srgbClr val="1F5E34"/>
-          </a:solidFill>
-          <a:ln/>
-        </p:spPr>
-      </p:sp>
-      <p:sp>
-        <p:nvSpPr>
-          <p:cNvPr id="10" name="Shape 8"/>
+            <a:srgbClr val="4E9A3E"/>
+          </a:solidFill>
+          <a:ln/>
+        </p:spPr>
+      </p:sp>
+      <p:sp>
+        <p:nvSpPr>
+          <p:cNvPr id="11" name="Shape 9"/>
           <p:cNvSpPr/>
           <p:nvPr/>
         </p:nvSpPr>
         <p:spPr>
           <a:xfrm rot="14400000">
-            <a:off x="8979408" y="3770048"/>
-            <a:ext cx="914400" cy="292608"/>
+            <a:off x="10015606" y="4726411"/>
+            <a:ext cx="512064" cy="163860"/>
           </a:xfrm>
           <a:prstGeom prst="roundRect">
             <a:avLst>
@@ -11641,21 +11763,21 @@
             </a:avLst>
           </a:prstGeom>
           <a:solidFill>
-            <a:srgbClr val="1F5E34"/>
-          </a:solidFill>
-          <a:ln/>
-        </p:spPr>
-      </p:sp>
-      <p:sp>
-        <p:nvSpPr>
-          <p:cNvPr id="11" name="Shape 9"/>
+            <a:srgbClr val="F2AD32"/>
+          </a:solidFill>
+          <a:ln/>
+        </p:spPr>
+      </p:sp>
+      <p:sp>
+        <p:nvSpPr>
+          <p:cNvPr id="12" name="Shape 10"/>
           <p:cNvSpPr/>
           <p:nvPr/>
         </p:nvSpPr>
         <p:spPr>
           <a:xfrm rot="16200000">
-            <a:off x="10149840" y="3456432"/>
-            <a:ext cx="914400" cy="292608"/>
+            <a:off x="10671048" y="4550786"/>
+            <a:ext cx="512064" cy="163860"/>
           </a:xfrm>
           <a:prstGeom prst="roundRect">
             <a:avLst>
@@ -11663,21 +11785,21 @@
             </a:avLst>
           </a:prstGeom>
           <a:solidFill>
-            <a:srgbClr val="1F5E34"/>
-          </a:solidFill>
-          <a:ln/>
-        </p:spPr>
-      </p:sp>
-      <p:sp>
-        <p:nvSpPr>
-          <p:cNvPr id="12" name="Shape 10"/>
+            <a:srgbClr val="4E9A3E"/>
+          </a:solidFill>
+          <a:ln/>
+        </p:spPr>
+      </p:sp>
+      <p:sp>
+        <p:nvSpPr>
+          <p:cNvPr id="13" name="Shape 11"/>
           <p:cNvSpPr/>
           <p:nvPr/>
         </p:nvSpPr>
         <p:spPr>
           <a:xfrm rot="18000000">
-            <a:off x="11320272" y="3770048"/>
-            <a:ext cx="914400" cy="292608"/>
+            <a:off x="11326490" y="4726411"/>
+            <a:ext cx="512064" cy="163860"/>
           </a:xfrm>
           <a:prstGeom prst="roundRect">
             <a:avLst>
@@ -11685,21 +11807,21 @@
             </a:avLst>
           </a:prstGeom>
           <a:solidFill>
-            <a:srgbClr val="1F5E34"/>
-          </a:solidFill>
-          <a:ln/>
-        </p:spPr>
-      </p:sp>
-      <p:sp>
-        <p:nvSpPr>
-          <p:cNvPr id="13" name="Shape 11"/>
+            <a:srgbClr val="F2AD32"/>
+          </a:solidFill>
+          <a:ln/>
+        </p:spPr>
+      </p:sp>
+      <p:sp>
+        <p:nvSpPr>
+          <p:cNvPr id="14" name="Shape 12"/>
           <p:cNvSpPr/>
           <p:nvPr/>
         </p:nvSpPr>
         <p:spPr>
           <a:xfrm rot="19800000">
-            <a:off x="12177088" y="4626864"/>
-            <a:ext cx="914400" cy="292608"/>
+            <a:off x="11806307" y="5206228"/>
+            <a:ext cx="512064" cy="163860"/>
           </a:xfrm>
           <a:prstGeom prst="roundRect">
             <a:avLst>
@@ -11707,61 +11829,61 @@
             </a:avLst>
           </a:prstGeom>
           <a:solidFill>
-            <a:srgbClr val="1F5E34"/>
-          </a:solidFill>
-          <a:ln/>
-        </p:spPr>
-      </p:sp>
-      <p:sp>
-        <p:nvSpPr>
-          <p:cNvPr id="14" name="Shape 12"/>
-          <p:cNvSpPr/>
-          <p:nvPr/>
-        </p:nvSpPr>
-        <p:spPr>
-          <a:xfrm>
-            <a:off x="8778240" y="4114800"/>
-            <a:ext cx="3657600" cy="3657600"/>
+            <a:srgbClr val="4E9A3E"/>
+          </a:solidFill>
+          <a:ln/>
+        </p:spPr>
+      </p:sp>
+      <p:sp>
+        <p:nvSpPr>
+          <p:cNvPr id="15" name="Shape 13"/>
+          <p:cNvSpPr/>
+          <p:nvPr/>
+        </p:nvSpPr>
+        <p:spPr>
+          <a:xfrm>
+            <a:off x="9902952" y="4919472"/>
+            <a:ext cx="2048256" cy="2048256"/>
           </a:xfrm>
           <a:prstGeom prst="ellipse">
             <a:avLst/>
           </a:prstGeom>
           <a:solidFill>
-            <a:srgbClr val="1F5E34"/>
-          </a:solidFill>
-          <a:ln/>
-        </p:spPr>
-      </p:sp>
-      <p:sp>
-        <p:nvSpPr>
-          <p:cNvPr id="15" name="Shape 13"/>
-          <p:cNvSpPr/>
-          <p:nvPr/>
-        </p:nvSpPr>
-        <p:spPr>
-          <a:xfrm>
-            <a:off x="9473184" y="4809744"/>
-            <a:ext cx="2267712" cy="2267712"/>
+            <a:srgbClr val="4E9A3E"/>
+          </a:solidFill>
+          <a:ln/>
+        </p:spPr>
+      </p:sp>
+      <p:sp>
+        <p:nvSpPr>
+          <p:cNvPr id="16" name="Shape 14"/>
+          <p:cNvSpPr/>
+          <p:nvPr/>
+        </p:nvSpPr>
+        <p:spPr>
+          <a:xfrm>
+            <a:off x="10292121" y="5308641"/>
+            <a:ext cx="1269919" cy="1269919"/>
           </a:xfrm>
           <a:prstGeom prst="ellipse">
             <a:avLst/>
           </a:prstGeom>
           <a:solidFill>
-            <a:srgbClr val="1A4C2C"/>
-          </a:solidFill>
-          <a:ln/>
-        </p:spPr>
-      </p:sp>
-      <p:sp>
-        <p:nvSpPr>
-          <p:cNvPr id="16" name="Shape 14"/>
-          <p:cNvSpPr/>
-          <p:nvPr/>
-        </p:nvSpPr>
-        <p:spPr>
-          <a:xfrm>
-            <a:off x="10241280" y="5321808"/>
-            <a:ext cx="731520" cy="731520"/>
+            <a:srgbClr val="F2AD32"/>
+          </a:solidFill>
+          <a:ln/>
+        </p:spPr>
+      </p:sp>
+      <p:sp>
+        <p:nvSpPr>
+          <p:cNvPr id="17" name="Shape 15"/>
+          <p:cNvSpPr/>
+          <p:nvPr/>
+        </p:nvSpPr>
+        <p:spPr>
+          <a:xfrm>
+            <a:off x="10773461" y="5411053"/>
+            <a:ext cx="307238" cy="307238"/>
           </a:xfrm>
           <a:prstGeom prst="ellipse">
             <a:avLst/>
@@ -11774,14 +11896,402 @@
       </p:sp>
       <p:sp>
         <p:nvSpPr>
-          <p:cNvPr id="17" name="Shape 15"/>
-          <p:cNvSpPr/>
-          <p:nvPr/>
-        </p:nvSpPr>
-        <p:spPr>
-          <a:xfrm>
-            <a:off x="9838944" y="5797296"/>
-            <a:ext cx="1536192" cy="1280160"/>
+          <p:cNvPr id="18" name="Shape 16"/>
+          <p:cNvSpPr/>
+          <p:nvPr/>
+        </p:nvSpPr>
+        <p:spPr>
+          <a:xfrm>
+            <a:off x="10660807" y="5800222"/>
+            <a:ext cx="532547" cy="573512"/>
+          </a:xfrm>
+          <a:prstGeom prst="triangle">
+            <a:avLst/>
+          </a:prstGeom>
+          <a:solidFill>
+            <a:srgbClr val="FFFFFF"/>
+          </a:solidFill>
+          <a:ln/>
+        </p:spPr>
+      </p:sp>
+      <p:sp>
+        <p:nvSpPr>
+          <p:cNvPr id="19" name="Shape 17"/>
+          <p:cNvSpPr/>
+          <p:nvPr/>
+        </p:nvSpPr>
+        <p:spPr>
+          <a:xfrm rot="-2520000">
+            <a:off x="10415016" y="5636362"/>
+            <a:ext cx="471099" cy="153619"/>
+          </a:xfrm>
+          <a:prstGeom prst="roundRect">
+            <a:avLst>
+              <a:gd name="adj" fmla="val 50000"/>
+            </a:avLst>
+          </a:prstGeom>
+          <a:solidFill>
+            <a:srgbClr val="FFFFFF"/>
+          </a:solidFill>
+          <a:ln/>
+        </p:spPr>
+      </p:sp>
+      <p:sp>
+        <p:nvSpPr>
+          <p:cNvPr id="20" name="Shape 18"/>
+          <p:cNvSpPr/>
+          <p:nvPr/>
+        </p:nvSpPr>
+        <p:spPr>
+          <a:xfrm rot="2520000">
+            <a:off x="10968045" y="5636362"/>
+            <a:ext cx="471099" cy="153619"/>
+          </a:xfrm>
+          <a:prstGeom prst="roundRect">
+            <a:avLst>
+              <a:gd name="adj" fmla="val 50000"/>
+            </a:avLst>
+          </a:prstGeom>
+          <a:solidFill>
+            <a:srgbClr val="FFFFFF"/>
+          </a:solidFill>
+          <a:ln/>
+        </p:spPr>
+      </p:sp>
+      <p:sp>
+        <p:nvSpPr>
+          <p:cNvPr id="21" name="Shape 19"/>
+          <p:cNvSpPr/>
+          <p:nvPr/>
+        </p:nvSpPr>
+        <p:spPr>
+          <a:xfrm>
+            <a:off x="891659" y="722486"/>
+            <a:ext cx="73609" cy="23555"/>
+          </a:xfrm>
+          <a:prstGeom prst="roundRect">
+            <a:avLst>
+              <a:gd name="adj" fmla="val 50000"/>
+            </a:avLst>
+          </a:prstGeom>
+          <a:solidFill>
+            <a:srgbClr val="F2AD32"/>
+          </a:solidFill>
+          <a:ln/>
+        </p:spPr>
+      </p:sp>
+      <p:sp>
+        <p:nvSpPr>
+          <p:cNvPr id="22" name="Shape 20"/>
+          <p:cNvSpPr/>
+          <p:nvPr/>
+        </p:nvSpPr>
+        <p:spPr>
+          <a:xfrm rot="1800000">
+            <a:off x="866413" y="816706"/>
+            <a:ext cx="73609" cy="23555"/>
+          </a:xfrm>
+          <a:prstGeom prst="roundRect">
+            <a:avLst>
+              <a:gd name="adj" fmla="val 50000"/>
+            </a:avLst>
+          </a:prstGeom>
+          <a:solidFill>
+            <a:srgbClr val="4E9A3E"/>
+          </a:solidFill>
+          <a:ln/>
+        </p:spPr>
+      </p:sp>
+      <p:sp>
+        <p:nvSpPr>
+          <p:cNvPr id="23" name="Shape 21"/>
+          <p:cNvSpPr/>
+          <p:nvPr/>
+        </p:nvSpPr>
+        <p:spPr>
+          <a:xfrm rot="3600000">
+            <a:off x="797439" y="885679"/>
+            <a:ext cx="73609" cy="23555"/>
+          </a:xfrm>
+          <a:prstGeom prst="roundRect">
+            <a:avLst>
+              <a:gd name="adj" fmla="val 50000"/>
+            </a:avLst>
+          </a:prstGeom>
+          <a:solidFill>
+            <a:srgbClr val="F2AD32"/>
+          </a:solidFill>
+          <a:ln/>
+        </p:spPr>
+      </p:sp>
+      <p:sp>
+        <p:nvSpPr>
+          <p:cNvPr id="24" name="Shape 22"/>
+          <p:cNvSpPr/>
+          <p:nvPr/>
+        </p:nvSpPr>
+        <p:spPr>
+          <a:xfrm rot="5400000">
+            <a:off x="703219" y="910925"/>
+            <a:ext cx="73609" cy="23555"/>
+          </a:xfrm>
+          <a:prstGeom prst="roundRect">
+            <a:avLst>
+              <a:gd name="adj" fmla="val 50000"/>
+            </a:avLst>
+          </a:prstGeom>
+          <a:solidFill>
+            <a:srgbClr val="4E9A3E"/>
+          </a:solidFill>
+          <a:ln/>
+        </p:spPr>
+      </p:sp>
+      <p:sp>
+        <p:nvSpPr>
+          <p:cNvPr id="25" name="Shape 23"/>
+          <p:cNvSpPr/>
+          <p:nvPr/>
+        </p:nvSpPr>
+        <p:spPr>
+          <a:xfrm rot="7200000">
+            <a:off x="609000" y="885679"/>
+            <a:ext cx="73609" cy="23555"/>
+          </a:xfrm>
+          <a:prstGeom prst="roundRect">
+            <a:avLst>
+              <a:gd name="adj" fmla="val 50000"/>
+            </a:avLst>
+          </a:prstGeom>
+          <a:solidFill>
+            <a:srgbClr val="F2AD32"/>
+          </a:solidFill>
+          <a:ln/>
+        </p:spPr>
+      </p:sp>
+      <p:sp>
+        <p:nvSpPr>
+          <p:cNvPr id="26" name="Shape 24"/>
+          <p:cNvSpPr/>
+          <p:nvPr/>
+        </p:nvSpPr>
+        <p:spPr>
+          <a:xfrm rot="9000000">
+            <a:off x="540026" y="816706"/>
+            <a:ext cx="73609" cy="23555"/>
+          </a:xfrm>
+          <a:prstGeom prst="roundRect">
+            <a:avLst>
+              <a:gd name="adj" fmla="val 50000"/>
+            </a:avLst>
+          </a:prstGeom>
+          <a:solidFill>
+            <a:srgbClr val="4E9A3E"/>
+          </a:solidFill>
+          <a:ln/>
+        </p:spPr>
+      </p:sp>
+      <p:sp>
+        <p:nvSpPr>
+          <p:cNvPr id="27" name="Shape 25"/>
+          <p:cNvSpPr/>
+          <p:nvPr/>
+        </p:nvSpPr>
+        <p:spPr>
+          <a:xfrm rot="10800000">
+            <a:off x="514780" y="722486"/>
+            <a:ext cx="73609" cy="23555"/>
+          </a:xfrm>
+          <a:prstGeom prst="roundRect">
+            <a:avLst>
+              <a:gd name="adj" fmla="val 50000"/>
+            </a:avLst>
+          </a:prstGeom>
+          <a:solidFill>
+            <a:srgbClr val="F2AD32"/>
+          </a:solidFill>
+          <a:ln/>
+        </p:spPr>
+      </p:sp>
+      <p:sp>
+        <p:nvSpPr>
+          <p:cNvPr id="28" name="Shape 26"/>
+          <p:cNvSpPr/>
+          <p:nvPr/>
+        </p:nvSpPr>
+        <p:spPr>
+          <a:xfrm rot="12600000">
+            <a:off x="540026" y="628266"/>
+            <a:ext cx="73609" cy="23555"/>
+          </a:xfrm>
+          <a:prstGeom prst="roundRect">
+            <a:avLst>
+              <a:gd name="adj" fmla="val 50000"/>
+            </a:avLst>
+          </a:prstGeom>
+          <a:solidFill>
+            <a:srgbClr val="4E9A3E"/>
+          </a:solidFill>
+          <a:ln/>
+        </p:spPr>
+      </p:sp>
+      <p:sp>
+        <p:nvSpPr>
+          <p:cNvPr id="29" name="Shape 27"/>
+          <p:cNvSpPr/>
+          <p:nvPr/>
+        </p:nvSpPr>
+        <p:spPr>
+          <a:xfrm rot="14400000">
+            <a:off x="609000" y="559292"/>
+            <a:ext cx="73609" cy="23555"/>
+          </a:xfrm>
+          <a:prstGeom prst="roundRect">
+            <a:avLst>
+              <a:gd name="adj" fmla="val 50000"/>
+            </a:avLst>
+          </a:prstGeom>
+          <a:solidFill>
+            <a:srgbClr val="F2AD32"/>
+          </a:solidFill>
+          <a:ln/>
+        </p:spPr>
+      </p:sp>
+      <p:sp>
+        <p:nvSpPr>
+          <p:cNvPr id="30" name="Shape 28"/>
+          <p:cNvSpPr/>
+          <p:nvPr/>
+        </p:nvSpPr>
+        <p:spPr>
+          <a:xfrm rot="16200000">
+            <a:off x="703219" y="534046"/>
+            <a:ext cx="73609" cy="23555"/>
+          </a:xfrm>
+          <a:prstGeom prst="roundRect">
+            <a:avLst>
+              <a:gd name="adj" fmla="val 50000"/>
+            </a:avLst>
+          </a:prstGeom>
+          <a:solidFill>
+            <a:srgbClr val="4E9A3E"/>
+          </a:solidFill>
+          <a:ln/>
+        </p:spPr>
+      </p:sp>
+      <p:sp>
+        <p:nvSpPr>
+          <p:cNvPr id="31" name="Shape 29"/>
+          <p:cNvSpPr/>
+          <p:nvPr/>
+        </p:nvSpPr>
+        <p:spPr>
+          <a:xfrm rot="18000000">
+            <a:off x="797439" y="559292"/>
+            <a:ext cx="73609" cy="23555"/>
+          </a:xfrm>
+          <a:prstGeom prst="roundRect">
+            <a:avLst>
+              <a:gd name="adj" fmla="val 50000"/>
+            </a:avLst>
+          </a:prstGeom>
+          <a:solidFill>
+            <a:srgbClr val="F2AD32"/>
+          </a:solidFill>
+          <a:ln/>
+        </p:spPr>
+      </p:sp>
+      <p:sp>
+        <p:nvSpPr>
+          <p:cNvPr id="32" name="Shape 30"/>
+          <p:cNvSpPr/>
+          <p:nvPr/>
+        </p:nvSpPr>
+        <p:spPr>
+          <a:xfrm rot="19800000">
+            <a:off x="866413" y="628266"/>
+            <a:ext cx="73609" cy="23555"/>
+          </a:xfrm>
+          <a:prstGeom prst="roundRect">
+            <a:avLst>
+              <a:gd name="adj" fmla="val 50000"/>
+            </a:avLst>
+          </a:prstGeom>
+          <a:solidFill>
+            <a:srgbClr val="4E9A3E"/>
+          </a:solidFill>
+          <a:ln/>
+        </p:spPr>
+      </p:sp>
+      <p:sp>
+        <p:nvSpPr>
+          <p:cNvPr id="33" name="Shape 31"/>
+          <p:cNvSpPr/>
+          <p:nvPr/>
+        </p:nvSpPr>
+        <p:spPr>
+          <a:xfrm>
+            <a:off x="592806" y="587045"/>
+            <a:ext cx="294437" cy="294437"/>
+          </a:xfrm>
+          <a:prstGeom prst="ellipse">
+            <a:avLst/>
+          </a:prstGeom>
+          <a:solidFill>
+            <a:srgbClr val="4E9A3E"/>
+          </a:solidFill>
+          <a:ln/>
+        </p:spPr>
+      </p:sp>
+      <p:sp>
+        <p:nvSpPr>
+          <p:cNvPr id="34" name="Shape 32"/>
+          <p:cNvSpPr/>
+          <p:nvPr/>
+        </p:nvSpPr>
+        <p:spPr>
+          <a:xfrm>
+            <a:off x="648749" y="642988"/>
+            <a:ext cx="182551" cy="182551"/>
+          </a:xfrm>
+          <a:prstGeom prst="ellipse">
+            <a:avLst/>
+          </a:prstGeom>
+          <a:solidFill>
+            <a:srgbClr val="F2AD32"/>
+          </a:solidFill>
+          <a:ln/>
+        </p:spPr>
+      </p:sp>
+      <p:sp>
+        <p:nvSpPr>
+          <p:cNvPr id="35" name="Shape 33"/>
+          <p:cNvSpPr/>
+          <p:nvPr/>
+        </p:nvSpPr>
+        <p:spPr>
+          <a:xfrm>
+            <a:off x="710580" y="684209"/>
+            <a:ext cx="58887" cy="58887"/>
+          </a:xfrm>
+          <a:prstGeom prst="ellipse">
+            <a:avLst/>
+          </a:prstGeom>
+          <a:solidFill>
+            <a:srgbClr val="FFFFFF"/>
+          </a:solidFill>
+          <a:ln/>
+        </p:spPr>
+      </p:sp>
+      <p:sp>
+        <p:nvSpPr>
+          <p:cNvPr id="36" name="Shape 34"/>
+          <p:cNvSpPr/>
+          <p:nvPr/>
+        </p:nvSpPr>
+        <p:spPr>
+          <a:xfrm>
+            <a:off x="678192" y="722486"/>
+            <a:ext cx="123663" cy="103053"/>
           </a:xfrm>
           <a:prstGeom prst="chord">
             <a:avLst>
@@ -11797,361 +12307,14 @@
       </p:sp>
       <p:sp>
         <p:nvSpPr>
-          <p:cNvPr id="18" name="Shape 16"/>
-          <p:cNvSpPr/>
-          <p:nvPr/>
-        </p:nvSpPr>
-        <p:spPr>
-          <a:xfrm>
-            <a:off x="846917" y="693847"/>
-            <a:ext cx="64008" cy="20483"/>
-          </a:xfrm>
-          <a:prstGeom prst="roundRect">
-            <a:avLst>
-              <a:gd name="adj" fmla="val 49999"/>
-            </a:avLst>
-          </a:prstGeom>
-          <a:solidFill>
-            <a:srgbClr val="F2AD32"/>
-          </a:solidFill>
-          <a:ln/>
-        </p:spPr>
-      </p:sp>
-      <p:sp>
-        <p:nvSpPr>
-          <p:cNvPr id="19" name="Shape 17"/>
-          <p:cNvSpPr/>
-          <p:nvPr/>
-        </p:nvSpPr>
-        <p:spPr>
-          <a:xfrm rot="1800000">
-            <a:off x="824964" y="775777"/>
-            <a:ext cx="64008" cy="20483"/>
-          </a:xfrm>
-          <a:prstGeom prst="roundRect">
-            <a:avLst>
-              <a:gd name="adj" fmla="val 49999"/>
-            </a:avLst>
-          </a:prstGeom>
-          <a:solidFill>
-            <a:srgbClr val="4E9A3E"/>
-          </a:solidFill>
-          <a:ln/>
-        </p:spPr>
-      </p:sp>
-      <p:sp>
-        <p:nvSpPr>
-          <p:cNvPr id="20" name="Shape 18"/>
-          <p:cNvSpPr/>
-          <p:nvPr/>
-        </p:nvSpPr>
-        <p:spPr>
-          <a:xfrm rot="3600000">
-            <a:off x="764987" y="835754"/>
-            <a:ext cx="64008" cy="20483"/>
-          </a:xfrm>
-          <a:prstGeom prst="roundRect">
-            <a:avLst>
-              <a:gd name="adj" fmla="val 49999"/>
-            </a:avLst>
-          </a:prstGeom>
-          <a:solidFill>
-            <a:srgbClr val="F2AD32"/>
-          </a:solidFill>
-          <a:ln/>
-        </p:spPr>
-      </p:sp>
-      <p:sp>
-        <p:nvSpPr>
-          <p:cNvPr id="21" name="Shape 19"/>
-          <p:cNvSpPr/>
-          <p:nvPr/>
-        </p:nvSpPr>
-        <p:spPr>
-          <a:xfrm rot="5400000">
-            <a:off x="683057" y="857707"/>
-            <a:ext cx="64008" cy="20483"/>
-          </a:xfrm>
-          <a:prstGeom prst="roundRect">
-            <a:avLst>
-              <a:gd name="adj" fmla="val 49999"/>
-            </a:avLst>
-          </a:prstGeom>
-          <a:solidFill>
-            <a:srgbClr val="4E9A3E"/>
-          </a:solidFill>
-          <a:ln/>
-        </p:spPr>
-      </p:sp>
-      <p:sp>
-        <p:nvSpPr>
-          <p:cNvPr id="22" name="Shape 20"/>
-          <p:cNvSpPr/>
-          <p:nvPr/>
-        </p:nvSpPr>
-        <p:spPr>
-          <a:xfrm rot="7200000">
-            <a:off x="601127" y="835754"/>
-            <a:ext cx="64008" cy="20483"/>
-          </a:xfrm>
-          <a:prstGeom prst="roundRect">
-            <a:avLst>
-              <a:gd name="adj" fmla="val 49999"/>
-            </a:avLst>
-          </a:prstGeom>
-          <a:solidFill>
-            <a:srgbClr val="F2AD32"/>
-          </a:solidFill>
-          <a:ln/>
-        </p:spPr>
-      </p:sp>
-      <p:sp>
-        <p:nvSpPr>
-          <p:cNvPr id="23" name="Shape 21"/>
-          <p:cNvSpPr/>
-          <p:nvPr/>
-        </p:nvSpPr>
-        <p:spPr>
-          <a:xfrm rot="9000000">
-            <a:off x="541149" y="775777"/>
-            <a:ext cx="64008" cy="20483"/>
-          </a:xfrm>
-          <a:prstGeom prst="roundRect">
-            <a:avLst>
-              <a:gd name="adj" fmla="val 49999"/>
-            </a:avLst>
-          </a:prstGeom>
-          <a:solidFill>
-            <a:srgbClr val="4E9A3E"/>
-          </a:solidFill>
-          <a:ln/>
-        </p:spPr>
-      </p:sp>
-      <p:sp>
-        <p:nvSpPr>
-          <p:cNvPr id="24" name="Shape 22"/>
-          <p:cNvSpPr/>
-          <p:nvPr/>
-        </p:nvSpPr>
-        <p:spPr>
-          <a:xfrm rot="10800000">
-            <a:off x="519196" y="693847"/>
-            <a:ext cx="64008" cy="20483"/>
-          </a:xfrm>
-          <a:prstGeom prst="roundRect">
-            <a:avLst>
-              <a:gd name="adj" fmla="val 49999"/>
-            </a:avLst>
-          </a:prstGeom>
-          <a:solidFill>
-            <a:srgbClr val="F2AD32"/>
-          </a:solidFill>
-          <a:ln/>
-        </p:spPr>
-      </p:sp>
-      <p:sp>
-        <p:nvSpPr>
-          <p:cNvPr id="25" name="Shape 23"/>
-          <p:cNvSpPr/>
-          <p:nvPr/>
-        </p:nvSpPr>
-        <p:spPr>
-          <a:xfrm rot="12600000">
-            <a:off x="541149" y="611916"/>
-            <a:ext cx="64008" cy="20483"/>
-          </a:xfrm>
-          <a:prstGeom prst="roundRect">
-            <a:avLst>
-              <a:gd name="adj" fmla="val 49999"/>
-            </a:avLst>
-          </a:prstGeom>
-          <a:solidFill>
-            <a:srgbClr val="4E9A3E"/>
-          </a:solidFill>
-          <a:ln/>
-        </p:spPr>
-      </p:sp>
-      <p:sp>
-        <p:nvSpPr>
-          <p:cNvPr id="26" name="Shape 24"/>
-          <p:cNvSpPr/>
-          <p:nvPr/>
-        </p:nvSpPr>
-        <p:spPr>
-          <a:xfrm rot="14400000">
-            <a:off x="601127" y="551939"/>
-            <a:ext cx="64008" cy="20483"/>
-          </a:xfrm>
-          <a:prstGeom prst="roundRect">
-            <a:avLst>
-              <a:gd name="adj" fmla="val 49999"/>
-            </a:avLst>
-          </a:prstGeom>
-          <a:solidFill>
-            <a:srgbClr val="F2AD32"/>
-          </a:solidFill>
-          <a:ln/>
-        </p:spPr>
-      </p:sp>
-      <p:sp>
-        <p:nvSpPr>
-          <p:cNvPr id="27" name="Shape 25"/>
-          <p:cNvSpPr/>
-          <p:nvPr/>
-        </p:nvSpPr>
-        <p:spPr>
-          <a:xfrm rot="16200000">
-            <a:off x="683057" y="529986"/>
-            <a:ext cx="64008" cy="20483"/>
-          </a:xfrm>
-          <a:prstGeom prst="roundRect">
-            <a:avLst>
-              <a:gd name="adj" fmla="val 49999"/>
-            </a:avLst>
-          </a:prstGeom>
-          <a:solidFill>
-            <a:srgbClr val="4E9A3E"/>
-          </a:solidFill>
-          <a:ln/>
-        </p:spPr>
-      </p:sp>
-      <p:sp>
-        <p:nvSpPr>
-          <p:cNvPr id="28" name="Shape 26"/>
-          <p:cNvSpPr/>
-          <p:nvPr/>
-        </p:nvSpPr>
-        <p:spPr>
-          <a:xfrm rot="18000000">
-            <a:off x="764987" y="551939"/>
-            <a:ext cx="64008" cy="20483"/>
-          </a:xfrm>
-          <a:prstGeom prst="roundRect">
-            <a:avLst>
-              <a:gd name="adj" fmla="val 49999"/>
-            </a:avLst>
-          </a:prstGeom>
-          <a:solidFill>
-            <a:srgbClr val="F2AD32"/>
-          </a:solidFill>
-          <a:ln/>
-        </p:spPr>
-      </p:sp>
-      <p:sp>
-        <p:nvSpPr>
-          <p:cNvPr id="29" name="Shape 27"/>
-          <p:cNvSpPr/>
-          <p:nvPr/>
-        </p:nvSpPr>
-        <p:spPr>
-          <a:xfrm rot="19800000">
-            <a:off x="824964" y="611916"/>
-            <a:ext cx="64008" cy="20483"/>
-          </a:xfrm>
-          <a:prstGeom prst="roundRect">
-            <a:avLst>
-              <a:gd name="adj" fmla="val 49999"/>
-            </a:avLst>
-          </a:prstGeom>
-          <a:solidFill>
-            <a:srgbClr val="4E9A3E"/>
-          </a:solidFill>
-          <a:ln/>
-        </p:spPr>
-      </p:sp>
-      <p:sp>
-        <p:nvSpPr>
-          <p:cNvPr id="30" name="Shape 28"/>
-          <p:cNvSpPr/>
-          <p:nvPr/>
-        </p:nvSpPr>
-        <p:spPr>
-          <a:xfrm>
-            <a:off x="587045" y="576072"/>
-            <a:ext cx="256032" cy="256032"/>
-          </a:xfrm>
-          <a:prstGeom prst="ellipse">
-            <a:avLst/>
-          </a:prstGeom>
-          <a:solidFill>
-            <a:srgbClr val="4E9A3E"/>
-          </a:solidFill>
-          <a:ln/>
-        </p:spPr>
-      </p:sp>
-      <p:sp>
-        <p:nvSpPr>
-          <p:cNvPr id="31" name="Shape 29"/>
-          <p:cNvSpPr/>
-          <p:nvPr/>
-        </p:nvSpPr>
-        <p:spPr>
-          <a:xfrm>
-            <a:off x="635691" y="624718"/>
-            <a:ext cx="158740" cy="158740"/>
-          </a:xfrm>
-          <a:prstGeom prst="ellipse">
-            <a:avLst/>
-          </a:prstGeom>
-          <a:solidFill>
-            <a:srgbClr val="F2AD32"/>
-          </a:solidFill>
-          <a:ln/>
-        </p:spPr>
-      </p:sp>
-      <p:sp>
-        <p:nvSpPr>
-          <p:cNvPr id="32" name="Shape 30"/>
-          <p:cNvSpPr/>
-          <p:nvPr/>
-        </p:nvSpPr>
-        <p:spPr>
-          <a:xfrm>
-            <a:off x="689458" y="660563"/>
-            <a:ext cx="51206" cy="51206"/>
-          </a:xfrm>
-          <a:prstGeom prst="ellipse">
-            <a:avLst/>
-          </a:prstGeom>
-          <a:solidFill>
-            <a:srgbClr val="FFFFFF"/>
-          </a:solidFill>
-          <a:ln/>
-        </p:spPr>
-      </p:sp>
-      <p:sp>
-        <p:nvSpPr>
-          <p:cNvPr id="33" name="Shape 31"/>
-          <p:cNvSpPr/>
-          <p:nvPr/>
-        </p:nvSpPr>
-        <p:spPr>
-          <a:xfrm>
-            <a:off x="661294" y="693847"/>
-            <a:ext cx="107533" cy="89611"/>
-          </a:xfrm>
-          <a:prstGeom prst="chord">
-            <a:avLst>
-              <a:gd name="adj1" fmla="val 10800000"/>
-              <a:gd name="adj2" fmla="val 21600000"/>
-            </a:avLst>
-          </a:prstGeom>
-          <a:solidFill>
-            <a:srgbClr val="FFFFFF"/>
-          </a:solidFill>
-          <a:ln/>
-        </p:spPr>
-      </p:sp>
-      <p:sp>
-        <p:nvSpPr>
-          <p:cNvPr id="34" name="Text 32"/>
+          <p:cNvPr id="37" name="Text 35"/>
           <p:cNvSpPr txBox="1"/>
           <p:nvPr/>
         </p:nvSpPr>
         <p:spPr>
           <a:xfrm>
-            <a:off x="907085" y="484632"/>
-            <a:ext cx="2377440" cy="274320"/>
+            <a:off x="960852" y="481889"/>
+            <a:ext cx="2734056" cy="315468"/>
           </a:xfrm>
           <a:prstGeom prst="rect">
             <a:avLst/>
@@ -12167,7 +12330,7 @@
               <a:buNone/>
             </a:pPr>
             <a:r>
-              <a:rPr lang="en-US" sz="1800" b="1" spc="100" kern="0" dirty="0">
+              <a:rPr lang="en-US" sz="2070" b="1" spc="100" kern="0" dirty="0">
                 <a:solidFill>
                   <a:srgbClr val="FFFFFF"/>
                 </a:solidFill>
@@ -12177,20 +12340,20 @@
               </a:rPr>
               <a:t>UNAD</a:t>
             </a:r>
-            <a:endParaRPr lang="en-US" sz="1800" dirty="0"/>
-          </a:p>
-        </p:txBody>
-      </p:sp>
-      <p:sp>
-        <p:nvSpPr>
-          <p:cNvPr id="35" name="Text 33"/>
+            <a:endParaRPr lang="en-US" sz="2070" dirty="0"/>
+          </a:p>
+        </p:txBody>
+      </p:sp>
+      <p:sp>
+        <p:nvSpPr>
+          <p:cNvPr id="38" name="Text 36"/>
           <p:cNvSpPr txBox="1"/>
           <p:nvPr/>
         </p:nvSpPr>
         <p:spPr>
           <a:xfrm>
-            <a:off x="907085" y="722376"/>
-            <a:ext cx="3017520" cy="182880"/>
+            <a:off x="960852" y="755294"/>
+            <a:ext cx="3470148" cy="210312"/>
           </a:xfrm>
           <a:prstGeom prst="rect">
             <a:avLst/>
@@ -12206,7 +12369,7 @@
               <a:buNone/>
             </a:pPr>
             <a:r>
-              <a:rPr lang="en-US" sz="750" dirty="0">
+              <a:rPr lang="en-US" sz="863" dirty="0">
                 <a:solidFill>
                   <a:srgbClr val="CFE3C4"/>
                 </a:solidFill>
@@ -12216,13 +12379,13 @@
               </a:rPr>
               <a:t>Universidad Nacional Abierta y a Distancia</a:t>
             </a:r>
-            <a:endParaRPr lang="en-US" sz="750" dirty="0"/>
+            <a:endParaRPr lang="en-US" sz="863" dirty="0"/>
           </a:p>
         </p:txBody>
       </p:sp>
       <p:pic>
         <p:nvPicPr>
-          <p:cNvPr id="36" name="Image 0" descr="preencoded.png">    </p:cNvPr>
+          <p:cNvPr id="39" name="Image 0" descr="preencoded.png">    </p:cNvPr>
           <p:cNvPicPr>
             <a:picLocks noChangeAspect="1"/>
           </p:cNvPicPr>
@@ -12246,7 +12409,7 @@
       </p:pic>
       <p:sp>
         <p:nvSpPr>
-          <p:cNvPr id="37" name="Text 34"/>
+          <p:cNvPr id="40" name="Text 37"/>
           <p:cNvSpPr txBox="1"/>
           <p:nvPr/>
         </p:nvSpPr>
@@ -12285,7 +12448,7 @@
       </p:sp>
       <p:sp>
         <p:nvSpPr>
-          <p:cNvPr id="38" name="Text 35"/>
+          <p:cNvPr id="41" name="Text 38"/>
           <p:cNvSpPr txBox="1"/>
           <p:nvPr/>
         </p:nvSpPr>
@@ -12347,7 +12510,7 @@
       </p:sp>
       <p:sp>
         <p:nvSpPr>
-          <p:cNvPr id="39" name="Shape 36"/>
+          <p:cNvPr id="42" name="Shape 39"/>
           <p:cNvSpPr/>
           <p:nvPr/>
         </p:nvSpPr>
@@ -12369,7 +12532,7 @@
       </p:sp>
       <p:sp>
         <p:nvSpPr>
-          <p:cNvPr id="40" name="Text 37"/>
+          <p:cNvPr id="43" name="Text 40"/>
           <p:cNvSpPr txBox="1"/>
           <p:nvPr/>
         </p:nvSpPr>
@@ -17357,8 +17520,8 @@
         </p:nvSpPr>
         <p:spPr>
           <a:xfrm>
-            <a:off x="10643616" y="601675"/>
-            <a:ext cx="475488" cy="475488"/>
+            <a:off x="10703052" y="387706"/>
+            <a:ext cx="356616" cy="356616"/>
           </a:xfrm>
           <a:prstGeom prst="ellipse">
             <a:avLst/>
@@ -17377,13 +17540,32 @@
         </p:nvSpPr>
         <p:spPr>
           <a:xfrm>
-            <a:off x="10382098" y="910742"/>
-            <a:ext cx="998525" cy="832104"/>
-          </a:xfrm>
-          <a:prstGeom prst="chord">
+            <a:off x="10572293" y="839419"/>
+            <a:ext cx="618134" cy="665683"/>
+          </a:xfrm>
+          <a:prstGeom prst="triangle">
+            <a:avLst/>
+          </a:prstGeom>
+          <a:solidFill>
+            <a:srgbClr val="FFFFFF"/>
+          </a:solidFill>
+          <a:ln/>
+        </p:spPr>
+      </p:sp>
+      <p:sp>
+        <p:nvSpPr>
+          <p:cNvPr id="18" name="Shape 16"/>
+          <p:cNvSpPr/>
+          <p:nvPr/>
+        </p:nvSpPr>
+        <p:spPr>
+          <a:xfrm rot="-2520000">
+            <a:off x="10287000" y="649224"/>
+            <a:ext cx="546811" cy="178308"/>
+          </a:xfrm>
+          <a:prstGeom prst="roundRect">
             <a:avLst>
-              <a:gd name="adj1" fmla="val 10800000"/>
-              <a:gd name="adj2" fmla="val 21600000"/>
+              <a:gd name="adj" fmla="val 50000"/>
             </a:avLst>
           </a:prstGeom>
           <a:solidFill>
@@ -17394,7 +17576,29 @@
       </p:sp>
       <p:sp>
         <p:nvSpPr>
-          <p:cNvPr id="18" name="Text 16"/>
+          <p:cNvPr id="19" name="Shape 17"/>
+          <p:cNvSpPr/>
+          <p:nvPr/>
+        </p:nvSpPr>
+        <p:spPr>
+          <a:xfrm rot="2520000">
+            <a:off x="10928909" y="649224"/>
+            <a:ext cx="546811" cy="178308"/>
+          </a:xfrm>
+          <a:prstGeom prst="roundRect">
+            <a:avLst>
+              <a:gd name="adj" fmla="val 50000"/>
+            </a:avLst>
+          </a:prstGeom>
+          <a:solidFill>
+            <a:srgbClr val="FFFFFF"/>
+          </a:solidFill>
+          <a:ln/>
+        </p:spPr>
+      </p:sp>
+      <p:sp>
+        <p:nvSpPr>
+          <p:cNvPr id="20" name="Text 18"/>
           <p:cNvSpPr txBox="1"/>
           <p:nvPr/>
         </p:nvSpPr>
@@ -17433,7 +17637,7 @@
       </p:sp>
       <p:sp>
         <p:nvSpPr>
-          <p:cNvPr id="19" name="Text 17"/>
+          <p:cNvPr id="21" name="Text 19"/>
           <p:cNvSpPr txBox="1"/>
           <p:nvPr/>
         </p:nvSpPr>
@@ -17495,7 +17699,7 @@
       </p:sp>
       <p:sp>
         <p:nvSpPr>
-          <p:cNvPr id="20" name="Text 18"/>
+          <p:cNvPr id="22" name="Text 20"/>
           <p:cNvSpPr txBox="1"/>
           <p:nvPr/>
         </p:nvSpPr>

</xml_diff>